<commit_message>
docs: índice con páginas e hipervínculos generado y exportación a PDF
Co-Authored-By: Claude Fable 5 <noreply@anthropic.com>
</commit_message>
<xml_diff>
--- a/informes/TFM_Raul_Hernando_Viadero_presentacion.pptx
+++ b/informes/TFM_Raul_Hernando_Viadero_presentacion.pptx
@@ -4,6 +4,9 @@
   <p:sldMasterIdLst>
     <p:sldMasterId id="2147483648" r:id="rId1"/>
   </p:sldMasterIdLst>
+  <p:notesMasterIdLst>
+    <p:notesMasterId r:id="rId15"/>
+  </p:notesMasterIdLst>
   <p:sldIdLst>
     <p:sldId id="256" r:id="rId2"/>
     <p:sldId id="257" r:id="rId3"/>
@@ -19,9 +22,6 @@
     <p:sldId id="267" r:id="rId13"/>
     <p:sldId id="268" r:id="rId14"/>
   </p:sldIdLst>
-  <p:notesMasterIdLst>
-    <p:notesMasterId r:id="rId15"/>
-  </p:notesMasterIdLst>
   <p:sldSz cx="12192000" cy="6858000"/>
   <p:notesSz cx="6858000" cy="12192000"/>
   <p:defaultTextStyle>
@@ -116,7 +116,20 @@
       </a:defRPr>
     </a:lvl9pPr>
   </p:defaultTextStyle>
+  <p:extLst>
+    <p:ext uri="{EFAFB233-063F-42B5-8137-9DF3F51BA10A}">
+      <p15:sldGuideLst xmlns:p15="http://schemas.microsoft.com/office/powerpoint/2012/main"/>
+    </p:ext>
+  </p:extLst>
 </p:presentation>
+</file>
+
+<file path=ppt/revisionInfo.xml><?xml version="1.0" encoding="utf-8"?>
+<p1510:revInfo xmlns:a="http://schemas.openxmlformats.org/drawingml/2006/main" xmlns:r="http://schemas.openxmlformats.org/officeDocument/2006/relationships" xmlns:p1510="http://schemas.microsoft.com/office/powerpoint/2015/10/main">
+  <p1510:revLst>
+    <p1510:client id="{A9DFA918-4425-EFD9-D10D-DC7C0453DE3C}" v="2" dt="2026-07-24T12:29:03.905"/>
+  </p1510:revLst>
+</p1510:revInfo>
 </file>
 
 <file path=ppt/notesMasters/notesMaster1.xml><?xml version="1.0" encoding="utf-8"?>
@@ -143,7 +156,7 @@
       </p:grpSpPr>
       <p:sp>
         <p:nvSpPr>
-          <p:cNvPr id="2" name="Header Placeholder 1"/>
+          <p:cNvPr id="2" name="Marcador de encabezado 1"/>
           <p:cNvSpPr>
             <a:spLocks noGrp="1"/>
           </p:cNvSpPr>
@@ -154,7 +167,7 @@
         <p:spPr>
           <a:xfrm>
             <a:off x="0" y="0"/>
-            <a:ext cx="2971800" cy="458788"/>
+            <a:ext cx="2971800" cy="611188"/>
           </a:xfrm>
           <a:prstGeom prst="rect">
             <a:avLst/>
@@ -168,13 +181,13 @@
             </a:lvl1pPr>
           </a:lstStyle>
           <a:p>
-            <a:endParaRPr lang="en-US"/>
-          </a:p>
-        </p:txBody>
-      </p:sp>
-      <p:sp>
-        <p:nvSpPr>
-          <p:cNvPr id="3" name="Date Placeholder 2"/>
+            <a:endParaRPr lang="es-ES"/>
+          </a:p>
+        </p:txBody>
+      </p:sp>
+      <p:sp>
+        <p:nvSpPr>
+          <p:cNvPr id="3" name="Marcador de fecha 2"/>
           <p:cNvSpPr>
             <a:spLocks noGrp="1"/>
           </p:cNvSpPr>
@@ -185,7 +198,7 @@
         <p:spPr>
           <a:xfrm>
             <a:off x="3884613" y="0"/>
-            <a:ext cx="2971800" cy="458788"/>
+            <a:ext cx="2971800" cy="611188"/>
           </a:xfrm>
           <a:prstGeom prst="rect">
             <a:avLst/>
@@ -199,17 +212,16 @@
             </a:lvl1pPr>
           </a:lstStyle>
           <a:p>
-            <a:fld id="{5282F153-3F37-0F45-9E97-73ACFA13230C}" type="datetimeFigureOut">
-              <a:rPr lang="en-US"/>
-              <a:t>7/23/19</a:t>
+            <a:fld id="{CF3AAC0F-E8B1-442F-9B95-EB016B89CC69}" type="datetimeFigureOut">
+              <a:t>24/07/2026</a:t>
             </a:fld>
-            <a:endParaRPr lang="en-US"/>
-          </a:p>
-        </p:txBody>
-      </p:sp>
-      <p:sp>
-        <p:nvSpPr>
-          <p:cNvPr id="4" name="Slide Image Placeholder 3"/>
+            <a:endParaRPr lang="es-ES"/>
+          </a:p>
+        </p:txBody>
+      </p:sp>
+      <p:sp>
+        <p:nvSpPr>
+          <p:cNvPr id="4" name="Marcador de imagen de diapositiva 3"/>
           <p:cNvSpPr>
             <a:spLocks noGrp="1" noRot="1" noChangeAspect="1"/>
           </p:cNvSpPr>
@@ -219,8 +231,8 @@
         </p:nvSpPr>
         <p:spPr>
           <a:xfrm>
-            <a:off x="685800" y="1143000"/>
-            <a:ext cx="5486400" cy="3086100"/>
+            <a:off x="-228600" y="1524000"/>
+            <a:ext cx="7315200" cy="4114800"/>
           </a:xfrm>
           <a:prstGeom prst="rect">
             <a:avLst/>
@@ -236,13 +248,13 @@
           <a:bodyPr vert="horz" lIns="91440" tIns="45720" rIns="91440" bIns="45720" rtlCol="0" anchor="ctr"/>
           <a:lstStyle/>
           <a:p>
-            <a:endParaRPr lang="en-US"/>
-          </a:p>
-        </p:txBody>
-      </p:sp>
-      <p:sp>
-        <p:nvSpPr>
-          <p:cNvPr id="5" name="Notes Placeholder 4"/>
+            <a:endParaRPr lang="es-ES"/>
+          </a:p>
+        </p:txBody>
+      </p:sp>
+      <p:sp>
+        <p:nvSpPr>
+          <p:cNvPr id="5" name="Marcador de notas 4"/>
           <p:cNvSpPr>
             <a:spLocks noGrp="1"/>
           </p:cNvSpPr>
@@ -252,8 +264,8 @@
         </p:nvSpPr>
         <p:spPr>
           <a:xfrm>
-            <a:off x="685800" y="4400550"/>
-            <a:ext cx="5486400" cy="3600450"/>
+            <a:off x="685800" y="5867400"/>
+            <a:ext cx="5486400" cy="4800600"/>
           </a:xfrm>
           <a:prstGeom prst="rect">
             <a:avLst/>
@@ -265,43 +277,43 @@
           <a:p>
             <a:pPr lvl="0"/>
             <a:r>
-              <a:rPr lang="en-US"/>
-              <a:t>Click to edit Master text styles</a:t>
+              <a:rPr lang="es-ES"/>
+              <a:t>Haga clic para modificar los estilos de texto del patrón</a:t>
             </a:r>
           </a:p>
           <a:p>
             <a:pPr lvl="1"/>
             <a:r>
-              <a:rPr lang="en-US"/>
-              <a:t>Second level</a:t>
+              <a:rPr lang="es-ES"/>
+              <a:t>Segundo nivel</a:t>
             </a:r>
           </a:p>
           <a:p>
             <a:pPr lvl="2"/>
             <a:r>
-              <a:rPr lang="en-US"/>
-              <a:t>Third level</a:t>
+              <a:rPr lang="es-ES"/>
+              <a:t>Tercer nivel</a:t>
             </a:r>
           </a:p>
           <a:p>
             <a:pPr lvl="3"/>
             <a:r>
-              <a:rPr lang="en-US"/>
-              <a:t>Fourth level</a:t>
+              <a:rPr lang="es-ES"/>
+              <a:t>Cuarto nivel</a:t>
             </a:r>
           </a:p>
           <a:p>
             <a:pPr lvl="4"/>
             <a:r>
-              <a:rPr lang="en-US"/>
-              <a:t>Fifth level</a:t>
-            </a:r>
-          </a:p>
-        </p:txBody>
-      </p:sp>
-      <p:sp>
-        <p:nvSpPr>
-          <p:cNvPr id="6" name="Footer Placeholder 5"/>
+              <a:rPr lang="es-ES"/>
+              <a:t>Quinto nivel</a:t>
+            </a:r>
+          </a:p>
+        </p:txBody>
+      </p:sp>
+      <p:sp>
+        <p:nvSpPr>
+          <p:cNvPr id="6" name="Marcador de pie de página 5"/>
           <p:cNvSpPr>
             <a:spLocks noGrp="1"/>
           </p:cNvSpPr>
@@ -311,8 +323,8 @@
         </p:nvSpPr>
         <p:spPr>
           <a:xfrm>
-            <a:off x="0" y="8685213"/>
-            <a:ext cx="2971800" cy="458787"/>
+            <a:off x="0" y="11580813"/>
+            <a:ext cx="2971800" cy="611187"/>
           </a:xfrm>
           <a:prstGeom prst="rect">
             <a:avLst/>
@@ -326,13 +338,13 @@
             </a:lvl1pPr>
           </a:lstStyle>
           <a:p>
-            <a:endParaRPr lang="en-US"/>
-          </a:p>
-        </p:txBody>
-      </p:sp>
-      <p:sp>
-        <p:nvSpPr>
-          <p:cNvPr id="7" name="Slide Number Placeholder 6"/>
+            <a:endParaRPr lang="es-ES"/>
+          </a:p>
+        </p:txBody>
+      </p:sp>
+      <p:sp>
+        <p:nvSpPr>
+          <p:cNvPr id="7" name="Marcador de número de diapositiva 6"/>
           <p:cNvSpPr>
             <a:spLocks noGrp="1"/>
           </p:cNvSpPr>
@@ -342,8 +354,8 @@
         </p:nvSpPr>
         <p:spPr>
           <a:xfrm>
-            <a:off x="3884613" y="8685213"/>
-            <a:ext cx="2971800" cy="458787"/>
+            <a:off x="3884613" y="11580813"/>
+            <a:ext cx="2971800" cy="611187"/>
           </a:xfrm>
           <a:prstGeom prst="rect">
             <a:avLst/>
@@ -357,18 +369,17 @@
             </a:lvl1pPr>
           </a:lstStyle>
           <a:p>
-            <a:fld id="{CE5E9CC1-C706-0F49-92D6-E571CC5EEA8F}" type="slidenum">
-              <a:rPr lang="en-US"/>
-              <a:t>‹#›</a:t>
+            <a:fld id="{7AC9A817-4D43-4147-980E-E7E87857AF73}" type="slidenum">
+              <a:t>‹Nº›</a:t>
             </a:fld>
-            <a:endParaRPr lang="en-US"/>
+            <a:endParaRPr lang="es-ES"/>
           </a:p>
         </p:txBody>
       </p:sp>
     </p:spTree>
     <p:extLst>
       <p:ext uri="{BB962C8B-B14F-4D97-AF65-F5344CB8AC3E}">
-        <p14:creationId xmlns:p14="http://schemas.microsoft.com/office/powerpoint/2010/main" val="1024086991"/>
+        <p14:creationId xmlns:p14="http://schemas.microsoft.com/office/powerpoint/2010/main" val="1304989816"/>
       </p:ext>
     </p:extLst>
   </p:cSld>
@@ -516,7 +527,6 @@
               <a:rPr lang="en-US" dirty="0"/>
               <a:t>Presentación del TFM. Sistema automático que verifica expedientes de préstamo: DNI + formulario.</a:t>
             </a:r>
-            <a:endParaRPr lang="en-US" dirty="0"/>
           </a:p>
         </p:txBody>
       </p:sp>
@@ -604,7 +614,6 @@
               <a:rPr lang="en-US" dirty="0"/>
               <a:t>F1 92,8% supera el objetivo del 90%. En GPU bajaría de 1 segundo por expediente.</a:t>
             </a:r>
-            <a:endParaRPr lang="en-US" dirty="0"/>
           </a:p>
         </p:txBody>
       </p:sp>
@@ -692,7 +701,6 @@
               <a:rPr lang="en-US" dirty="0"/>
               <a:t>Streamlit + FastAPI + Docker Compose. Demo en vivo disponible en localhost:8501.</a:t>
             </a:r>
-            <a:endParaRPr lang="en-US" dirty="0"/>
           </a:p>
         </p:txBody>
       </p:sp>
@@ -780,7 +788,6 @@
               <a:rPr lang="en-US" dirty="0"/>
               <a:t>Cuatro conclusiones para no técnicos: datos sintéticos, eslabón débil, validaciones aritméticas, explicabilidad.</a:t>
             </a:r>
-            <a:endParaRPr lang="en-US" dirty="0"/>
           </a:p>
         </p:txBody>
       </p:sp>
@@ -868,7 +875,6 @@
               <a:rPr lang="en-US" dirty="0"/>
               <a:t>Cierre con los dos enlaces de entrega: GitHub (código) y Drive (entregables).</a:t>
             </a:r>
-            <a:endParaRPr lang="en-US" dirty="0"/>
           </a:p>
         </p:txBody>
       </p:sp>
@@ -956,7 +962,6 @@
               <a:rPr lang="en-US" dirty="0"/>
               <a:t>Tres dolores: coste, inconsistencia entre revisores y fraude digital sofisticado.</a:t>
             </a:r>
-            <a:endParaRPr lang="en-US" dirty="0"/>
           </a:p>
         </p:txBody>
       </p:sp>
@@ -1044,7 +1049,6 @@
               <a:rPr lang="en-US" dirty="0"/>
               <a:t>Sistema de cribado: no sustituye al analista, filtra el 90% de casos claros.</a:t>
             </a:r>
-            <a:endParaRPr lang="en-US" dirty="0"/>
           </a:p>
         </p:txBody>
       </p:sp>
@@ -1132,7 +1136,6 @@
               <a:rPr lang="en-US" dirty="0"/>
               <a:t>Pipeline: YOLO detecta, EasyOCR lee, postprocesador corrige, ResNet autentica, motor de reglas valida, veredicto final.</a:t>
             </a:r>
-            <a:endParaRPr lang="en-US" dirty="0"/>
           </a:p>
         </p:txBody>
       </p:sp>
@@ -1220,7 +1223,6 @@
               <a:rPr lang="en-US" dirty="0"/>
               <a:t>Datos sintéticos con Faker es_ES + Pillow. Reproducible con semilla 42. Ventaja RGPD y de anotación exacta.</a:t>
             </a:r>
-            <a:endParaRPr lang="en-US" dirty="0"/>
           </a:p>
         </p:txBody>
       </p:sp>
@@ -1308,7 +1310,6 @@
               <a:rPr lang="en-US" dirty="0"/>
               <a:t>YOLO mAP50 99,5% en ambos modelos. El postprocesador sube la precisión de importes de &lt;60% a ~90%.</a:t>
             </a:r>
-            <a:endParaRPr lang="en-US" dirty="0"/>
           </a:p>
         </p:txBody>
       </p:sp>
@@ -1396,7 +1397,6 @@
               <a:rPr lang="en-US" dirty="0"/>
               <a:t>Reglas con severidad. Similitud tolerante a errores de OCR (Levenshtein 85%). Verificaciones aritméticas gratis: letra NIF, dígitos MRZ, cuota francesa.</a:t>
             </a:r>
-            <a:endParaRPr lang="en-US" dirty="0"/>
           </a:p>
         </p:txBody>
       </p:sp>
@@ -1484,7 +1484,6 @@
               <a:rPr lang="en-US" dirty="0"/>
               <a:t>Caso real del split de test. El analista vería este resultado y podría tramitar sin revisar nada.</a:t>
             </a:r>
-            <a:endParaRPr lang="en-US" dirty="0"/>
           </a:p>
         </p:txBody>
       </p:sp>
@@ -1572,7 +1571,6 @@
               <a:rPr lang="en-US" dirty="0"/>
               <a:t>Transparencia: el detalle por regla convierte un 'no' opaco en información accionable.</a:t>
             </a:r>
-            <a:endParaRPr lang="en-US" dirty="0"/>
           </a:p>
         </p:txBody>
       </p:sp>
@@ -1645,6 +1643,11 @@
 <file path=ppt/slideMasters/slideMaster1.xml><?xml version="1.0" encoding="utf-8"?>
 <p:sldMaster xmlns:a="http://schemas.openxmlformats.org/drawingml/2006/main" xmlns:r="http://schemas.openxmlformats.org/officeDocument/2006/relationships" xmlns:p="http://schemas.openxmlformats.org/presentationml/2006/main">
   <p:cSld>
+    <p:bg>
+      <p:bgRef idx="1001">
+        <a:schemeClr val="bg1"/>
+      </p:bgRef>
+    </p:bg>
     <p:spTree>
       <p:nvGrpSpPr>
         <p:cNvPr id="1" name=""/>
@@ -1927,6 +1930,7 @@
         <a:solidFill>
           <a:srgbClr val="BA0C2F"/>
         </a:solidFill>
+        <a:effectLst/>
       </p:bgPr>
     </p:bg>
     <p:spTree>
@@ -1964,11 +1968,11 @@
           <a:bodyPr wrap="square" rtlCol="0" anchor="ctr"/>
           <a:lstStyle/>
           <a:p>
-            <a:pPr algn="ctr" indent="0" marL="0">
-              <a:buNone/>
-            </a:pPr>
-            <a:r>
-              <a:rPr lang="en-US" sz="1600" spc="400" kern="0" dirty="0">
+            <a:pPr marL="0" indent="0" algn="ctr">
+              <a:buNone/>
+            </a:pPr>
+            <a:r>
+              <a:rPr lang="en-US" sz="1600" kern="0" spc="400" dirty="0">
                 <a:solidFill>
                   <a:srgbClr val="F2C8D0"/>
                 </a:solidFill>
@@ -2003,7 +2007,7 @@
           <a:bodyPr wrap="square" rtlCol="0" anchor="ctr"/>
           <a:lstStyle/>
           <a:p>
-            <a:pPr algn="ctr" indent="0" marL="0">
+            <a:pPr marL="0" indent="0" algn="ctr">
               <a:buNone/>
             </a:pPr>
             <a:r>
@@ -2020,7 +2024,7 @@
             <a:endParaRPr lang="en-US" sz="3600" dirty="0"/>
           </a:p>
           <a:p>
-            <a:pPr algn="ctr" indent="0" marL="0">
+            <a:pPr marL="0" indent="0" algn="ctr">
               <a:buNone/>
             </a:pPr>
             <a:r>
@@ -2037,7 +2041,7 @@
             <a:endParaRPr lang="en-US" sz="3600" dirty="0"/>
           </a:p>
           <a:p>
-            <a:pPr algn="ctr" indent="0" marL="0">
+            <a:pPr marL="0" indent="0" algn="ctr">
               <a:buNone/>
             </a:pPr>
             <a:r>
@@ -2098,7 +2102,7 @@
           <a:bodyPr wrap="square" lIns="0" tIns="0" rIns="0" bIns="0" rtlCol="0" anchor="ctr"/>
           <a:lstStyle/>
           <a:p>
-            <a:pPr algn="ctr" indent="0" marL="0">
+            <a:pPr marL="0" indent="0" algn="ctr">
               <a:buNone/>
             </a:pPr>
             <a:r>
@@ -2112,9 +2116,6 @@
               </a:rPr>
               <a:t>Autor: </a:t>
             </a:r>
-            <a:pPr algn="ctr" indent="0" marL="0">
-              <a:buNone/>
-            </a:pPr>
             <a:r>
               <a:rPr lang="en-US" sz="1600" dirty="0">
                 <a:solidFill>
@@ -2127,9 +2128,6 @@
               <a:t>Raúl Hernando Viadero
 </a:t>
             </a:r>
-            <a:pPr algn="ctr" indent="0" marL="0">
-              <a:buNone/>
-            </a:pPr>
             <a:r>
               <a:rPr lang="en-US" sz="1600" b="1" dirty="0">
                 <a:solidFill>
@@ -2141,9 +2139,6 @@
               </a:rPr>
               <a:t>Tutor: </a:t>
             </a:r>
-            <a:pPr algn="ctr" indent="0" marL="0">
-              <a:buNone/>
-            </a:pPr>
             <a:r>
               <a:rPr lang="en-US" sz="1600" dirty="0">
                 <a:solidFill>
@@ -2180,7 +2175,7 @@
           <a:bodyPr wrap="square" rtlCol="0" anchor="ctr"/>
           <a:lstStyle/>
           <a:p>
-            <a:pPr algn="ctr" indent="0" marL="0">
+            <a:pPr marL="0" indent="0" algn="ctr">
               <a:buNone/>
             </a:pPr>
             <a:r>
@@ -2214,6 +2209,7 @@
         <a:solidFill>
           <a:srgbClr val="FFFFFF"/>
         </a:solidFill>
+        <a:effectLst/>
       </p:bgPr>
     </p:bg>
     <p:spTree>
@@ -2251,7 +2247,7 @@
           <a:bodyPr wrap="square" rtlCol="0" anchor="ctr"/>
           <a:lstStyle/>
           <a:p>
-            <a:pPr indent="0" marL="0">
+            <a:pPr marL="0" indent="0">
               <a:buNone/>
             </a:pPr>
             <a:r>
@@ -2290,7 +2286,7 @@
           <a:bodyPr wrap="square" rtlCol="0" anchor="ctr"/>
           <a:lstStyle/>
           <a:p>
-            <a:pPr indent="0" marL="0">
+            <a:pPr marL="0" indent="0">
               <a:buNone/>
             </a:pPr>
             <a:r>
@@ -2329,7 +2325,7 @@
           <a:bodyPr wrap="square" lIns="0" tIns="0" rIns="0" bIns="0" rtlCol="0" anchor="ctr"/>
           <a:lstStyle/>
           <a:p>
-            <a:pPr algn="ctr" indent="0" marL="0">
+            <a:pPr marL="0" indent="0" algn="ctr">
               <a:buNone/>
             </a:pPr>
             <a:r>
@@ -2368,7 +2364,7 @@
           <a:bodyPr wrap="square" lIns="0" tIns="0" rIns="0" bIns="0" rtlCol="0" anchor="ctr"/>
           <a:lstStyle/>
           <a:p>
-            <a:pPr algn="ctr" indent="0" marL="0">
+            <a:pPr marL="0" indent="0" algn="ctr">
               <a:buNone/>
             </a:pPr>
             <a:r>
@@ -2385,7 +2381,7 @@
             <a:endParaRPr lang="en-US" sz="1300" dirty="0"/>
           </a:p>
           <a:p>
-            <a:pPr algn="ctr" indent="0" marL="0">
+            <a:pPr marL="0" indent="0" algn="ctr">
               <a:buNone/>
             </a:pPr>
             <a:r>
@@ -2424,7 +2420,7 @@
           <a:bodyPr wrap="square" lIns="0" tIns="0" rIns="0" bIns="0" rtlCol="0" anchor="ctr"/>
           <a:lstStyle/>
           <a:p>
-            <a:pPr algn="ctr" indent="0" marL="0">
+            <a:pPr marL="0" indent="0" algn="ctr">
               <a:buNone/>
             </a:pPr>
             <a:r>
@@ -2463,7 +2459,7 @@
           <a:bodyPr wrap="square" lIns="0" tIns="0" rIns="0" bIns="0" rtlCol="0" anchor="ctr"/>
           <a:lstStyle/>
           <a:p>
-            <a:pPr algn="ctr" indent="0" marL="0">
+            <a:pPr marL="0" indent="0" algn="ctr">
               <a:buNone/>
             </a:pPr>
             <a:r>
@@ -2480,7 +2476,7 @@
             <a:endParaRPr lang="en-US" sz="1300" dirty="0"/>
           </a:p>
           <a:p>
-            <a:pPr algn="ctr" indent="0" marL="0">
+            <a:pPr marL="0" indent="0" algn="ctr">
               <a:buNone/>
             </a:pPr>
             <a:r>
@@ -2519,7 +2515,7 @@
           <a:bodyPr wrap="square" lIns="0" tIns="0" rIns="0" bIns="0" rtlCol="0" anchor="ctr"/>
           <a:lstStyle/>
           <a:p>
-            <a:pPr algn="ctr" indent="0" marL="0">
+            <a:pPr marL="0" indent="0" algn="ctr">
               <a:buNone/>
             </a:pPr>
             <a:r>
@@ -2558,7 +2554,7 @@
           <a:bodyPr wrap="square" lIns="0" tIns="0" rIns="0" bIns="0" rtlCol="0" anchor="ctr"/>
           <a:lstStyle/>
           <a:p>
-            <a:pPr algn="ctr" indent="0" marL="0">
+            <a:pPr marL="0" indent="0" algn="ctr">
               <a:buNone/>
             </a:pPr>
             <a:r>
@@ -2575,7 +2571,7 @@
             <a:endParaRPr lang="en-US" sz="1300" dirty="0"/>
           </a:p>
           <a:p>
-            <a:pPr algn="ctr" indent="0" marL="0">
+            <a:pPr marL="0" indent="0" algn="ctr">
               <a:buNone/>
             </a:pPr>
             <a:r>
@@ -2614,7 +2610,7 @@
           </a:solidFill>
           <a:ln/>
           <a:effectLst>
-            <a:outerShdw sx="100000" sy="100000" kx="0" ky="0" algn="bl" rotWithShape="0" blurRad="76200" dist="25400" dir="5400000">
+            <a:outerShdw blurRad="76200" dist="25400" dir="5400000" algn="bl" rotWithShape="0">
               <a:srgbClr val="999999">
                 <a:alpha val="35000"/>
               </a:srgbClr>
@@ -2643,7 +2639,7 @@
           <a:bodyPr wrap="square" lIns="0" tIns="0" rIns="0" bIns="0" rtlCol="0" anchor="ctr"/>
           <a:lstStyle/>
           <a:p>
-            <a:pPr indent="0" marL="0">
+            <a:pPr marL="0" indent="0">
               <a:buNone/>
             </a:pPr>
             <a:r>
@@ -2699,42 +2695,8 @@
                 <a:cs typeface="Calibri" pitchFamily="34" charset="-120"/>
               </a:rPr>
               <a:t>La confianza distingue: los expedientes correctos puntúan de media 93% y los problemáticos 68% — la zona intermedia puede priorizarse para revisión humana.
-</a:t>
-            </a:r>
-            <a:pPr indent="0" marL="0">
-              <a:spcAft>
-                <a:spcPts val="800"/>
-              </a:spcAft>
-              <a:buNone/>
-            </a:pPr>
-            <a:r>
-              <a:rPr lang="en-US" sz="1350" dirty="0">
-                <a:solidFill>
-                  <a:srgbClr val="404040"/>
-                </a:solidFill>
-                <a:latin typeface="Calibri" pitchFamily="34" charset="0"/>
-                <a:ea typeface="Calibri" pitchFamily="34" charset="-122"/>
-                <a:cs typeface="Calibri" pitchFamily="34" charset="-120"/>
-              </a:rPr>
-              <a:t>Detección conservadora del fraude: cuando el sistema marca un documento como manipulado, acierta el 100% de las veces — cero falsas alarmas.
-</a:t>
-            </a:r>
-            <a:pPr indent="0" marL="0">
-              <a:spcAft>
-                <a:spcPts val="800"/>
-              </a:spcAft>
-              <a:buNone/>
-            </a:pPr>
-            <a:r>
-              <a:rPr lang="en-US" sz="1350" dirty="0">
-                <a:solidFill>
-                  <a:srgbClr val="404040"/>
-                </a:solidFill>
-                <a:latin typeface="Calibri" pitchFamily="34" charset="0"/>
-                <a:ea typeface="Calibri" pitchFamily="34" charset="-122"/>
-                <a:cs typeface="Calibri" pitchFamily="34" charset="-120"/>
-              </a:rPr>
-              <a:t>Calidad de software: 77 tests automáticos y despliegue reproducible con un solo comando (Docker).</a:t>
+Detección conservadora del fraude: cuando el sistema marca un documento como manipulado, acierta el 100% de las veces — cero falsas alarmas.
+Calidad de software: 77 tests automáticos y despliegue reproducible con un solo comando (Docker).</a:t>
             </a:r>
             <a:endParaRPr lang="en-US" sz="1350" dirty="0"/>
           </a:p>
@@ -2756,6 +2718,7 @@
         <a:solidFill>
           <a:srgbClr val="FFFFFF"/>
         </a:solidFill>
+        <a:effectLst/>
       </p:bgPr>
     </p:bg>
     <p:spTree>
@@ -2793,7 +2756,7 @@
           <a:bodyPr wrap="square" rtlCol="0" anchor="ctr"/>
           <a:lstStyle/>
           <a:p>
-            <a:pPr indent="0" marL="0">
+            <a:pPr marL="0" indent="0">
               <a:buNone/>
             </a:pPr>
             <a:r>
@@ -2832,7 +2795,7 @@
           <a:bodyPr wrap="square" rtlCol="0" anchor="ctr"/>
           <a:lstStyle/>
           <a:p>
-            <a:pPr indent="0" marL="0">
+            <a:pPr marL="0" indent="0">
               <a:buNone/>
             </a:pPr>
             <a:r>
@@ -2871,7 +2834,7 @@
           </a:solidFill>
           <a:ln/>
           <a:effectLst>
-            <a:outerShdw sx="100000" sy="100000" kx="0" ky="0" algn="bl" rotWithShape="0" blurRad="76200" dist="25400" dir="5400000">
+            <a:outerShdw blurRad="76200" dist="25400" dir="5400000" algn="bl" rotWithShape="0">
               <a:srgbClr val="999999">
                 <a:alpha val="35000"/>
               </a:srgbClr>
@@ -2900,7 +2863,7 @@
           <a:bodyPr wrap="square" lIns="0" tIns="0" rIns="0" bIns="0" rtlCol="0" anchor="ctr"/>
           <a:lstStyle/>
           <a:p>
-            <a:pPr indent="0" marL="0">
+            <a:pPr marL="0" indent="0">
               <a:buNone/>
             </a:pPr>
             <a:r>
@@ -2936,7 +2899,7 @@
           <a:bodyPr wrap="square" lIns="0" tIns="0" rIns="0" bIns="0" rtlCol="0" anchor="ctr"/>
           <a:lstStyle/>
           <a:p>
-            <a:pPr indent="0" marL="0">
+            <a:pPr marL="0" indent="0">
               <a:buNone/>
             </a:pPr>
             <a:r>
@@ -2975,7 +2938,7 @@
           <a:bodyPr wrap="square" lIns="0" tIns="0" rIns="0" bIns="0" rtlCol="0" anchor="ctr"/>
           <a:lstStyle/>
           <a:p>
-            <a:pPr indent="0" marL="0">
+            <a:pPr marL="0" indent="0">
               <a:buNone/>
             </a:pPr>
             <a:r>
@@ -3014,7 +2977,7 @@
           </a:solidFill>
           <a:ln/>
           <a:effectLst>
-            <a:outerShdw sx="100000" sy="100000" kx="0" ky="0" algn="bl" rotWithShape="0" blurRad="76200" dist="25400" dir="5400000">
+            <a:outerShdw blurRad="76200" dist="25400" dir="5400000" algn="bl" rotWithShape="0">
               <a:srgbClr val="999999">
                 <a:alpha val="35000"/>
               </a:srgbClr>
@@ -3043,7 +3006,7 @@
           <a:bodyPr wrap="square" lIns="0" tIns="0" rIns="0" bIns="0" rtlCol="0" anchor="ctr"/>
           <a:lstStyle/>
           <a:p>
-            <a:pPr indent="0" marL="0">
+            <a:pPr marL="0" indent="0">
               <a:buNone/>
             </a:pPr>
             <a:r>
@@ -3079,7 +3042,7 @@
           <a:bodyPr wrap="square" lIns="0" tIns="0" rIns="0" bIns="0" rtlCol="0" anchor="ctr"/>
           <a:lstStyle/>
           <a:p>
-            <a:pPr indent="0" marL="0">
+            <a:pPr marL="0" indent="0">
               <a:buNone/>
             </a:pPr>
             <a:r>
@@ -3118,7 +3081,7 @@
           <a:bodyPr wrap="square" lIns="0" tIns="0" rIns="0" bIns="0" rtlCol="0" anchor="ctr"/>
           <a:lstStyle/>
           <a:p>
-            <a:pPr indent="0" marL="0">
+            <a:pPr marL="0" indent="0">
               <a:buNone/>
             </a:pPr>
             <a:r>
@@ -3157,7 +3120,7 @@
           </a:solidFill>
           <a:ln/>
           <a:effectLst>
-            <a:outerShdw sx="100000" sy="100000" kx="0" ky="0" algn="bl" rotWithShape="0" blurRad="76200" dist="25400" dir="5400000">
+            <a:outerShdw blurRad="76200" dist="25400" dir="5400000" algn="bl" rotWithShape="0">
               <a:srgbClr val="999999">
                 <a:alpha val="35000"/>
               </a:srgbClr>
@@ -3186,7 +3149,7 @@
           <a:bodyPr wrap="square" lIns="0" tIns="0" rIns="0" bIns="0" rtlCol="0" anchor="ctr"/>
           <a:lstStyle/>
           <a:p>
-            <a:pPr indent="0" marL="0">
+            <a:pPr marL="0" indent="0">
               <a:buNone/>
             </a:pPr>
             <a:r>
@@ -3222,7 +3185,7 @@
           <a:bodyPr wrap="square" lIns="0" tIns="0" rIns="0" bIns="0" rtlCol="0" anchor="ctr"/>
           <a:lstStyle/>
           <a:p>
-            <a:pPr indent="0" marL="0">
+            <a:pPr marL="0" indent="0">
               <a:buNone/>
             </a:pPr>
             <a:r>
@@ -3261,7 +3224,7 @@
           <a:bodyPr wrap="square" lIns="0" tIns="0" rIns="0" bIns="0" rtlCol="0" anchor="ctr"/>
           <a:lstStyle/>
           <a:p>
-            <a:pPr indent="0" marL="0">
+            <a:pPr marL="0" indent="0">
               <a:buNone/>
             </a:pPr>
             <a:r>
@@ -3300,7 +3263,7 @@
           </a:solidFill>
           <a:ln/>
           <a:effectLst>
-            <a:outerShdw sx="100000" sy="100000" kx="0" ky="0" algn="bl" rotWithShape="0" blurRad="76200" dist="25400" dir="5400000">
+            <a:outerShdw blurRad="76200" dist="25400" dir="5400000" algn="bl" rotWithShape="0">
               <a:srgbClr val="999999">
                 <a:alpha val="35000"/>
               </a:srgbClr>
@@ -3329,7 +3292,7 @@
           <a:bodyPr wrap="square" lIns="0" tIns="0" rIns="0" bIns="0" rtlCol="0" anchor="ctr"/>
           <a:lstStyle/>
           <a:p>
-            <a:pPr indent="0" marL="0">
+            <a:pPr marL="0" indent="0">
               <a:buNone/>
             </a:pPr>
             <a:r>
@@ -3365,7 +3328,7 @@
           <a:bodyPr wrap="square" lIns="0" tIns="0" rIns="0" bIns="0" rtlCol="0" anchor="ctr"/>
           <a:lstStyle/>
           <a:p>
-            <a:pPr indent="0" marL="0">
+            <a:pPr marL="0" indent="0">
               <a:buNone/>
             </a:pPr>
             <a:r>
@@ -3404,7 +3367,7 @@
           <a:bodyPr wrap="square" lIns="0" tIns="0" rIns="0" bIns="0" rtlCol="0" anchor="ctr"/>
           <a:lstStyle/>
           <a:p>
-            <a:pPr indent="0" marL="0">
+            <a:pPr marL="0" indent="0">
               <a:buNone/>
             </a:pPr>
             <a:r>
@@ -3438,6 +3401,7 @@
         <a:solidFill>
           <a:srgbClr val="FFFFFF"/>
         </a:solidFill>
+        <a:effectLst/>
       </p:bgPr>
     </p:bg>
     <p:spTree>
@@ -3475,7 +3439,7 @@
           <a:bodyPr wrap="square" rtlCol="0" anchor="ctr"/>
           <a:lstStyle/>
           <a:p>
-            <a:pPr indent="0" marL="0">
+            <a:pPr marL="0" indent="0">
               <a:buNone/>
             </a:pPr>
             <a:r>
@@ -3514,7 +3478,7 @@
           <a:bodyPr wrap="square" rtlCol="0" anchor="ctr"/>
           <a:lstStyle/>
           <a:p>
-            <a:pPr indent="0" marL="0">
+            <a:pPr marL="0" indent="0">
               <a:buNone/>
             </a:pPr>
             <a:r>
@@ -3553,7 +3517,7 @@
           </a:solidFill>
           <a:ln/>
           <a:effectLst>
-            <a:outerShdw sx="100000" sy="100000" kx="0" ky="0" algn="bl" rotWithShape="0" blurRad="76200" dist="25400" dir="5400000">
+            <a:outerShdw blurRad="76200" dist="25400" dir="5400000" algn="bl" rotWithShape="0">
               <a:srgbClr val="999999">
                 <a:alpha val="35000"/>
               </a:srgbClr>
@@ -3602,7 +3566,7 @@
           <a:bodyPr wrap="square" lIns="0" tIns="0" rIns="0" bIns="0" rtlCol="0" anchor="ctr"/>
           <a:lstStyle/>
           <a:p>
-            <a:pPr algn="ctr" indent="0" marL="0">
+            <a:pPr marL="0" indent="0" algn="ctr">
               <a:buNone/>
             </a:pPr>
             <a:r>
@@ -3641,7 +3605,7 @@
           <a:bodyPr wrap="square" lIns="0" tIns="0" rIns="0" bIns="0" rtlCol="0" anchor="ctr"/>
           <a:lstStyle/>
           <a:p>
-            <a:pPr indent="0" marL="0">
+            <a:pPr marL="0" indent="0">
               <a:buNone/>
             </a:pPr>
             <a:r>
@@ -3680,7 +3644,7 @@
           <a:bodyPr wrap="square" lIns="0" tIns="0" rIns="0" bIns="0" rtlCol="0" anchor="ctr"/>
           <a:lstStyle/>
           <a:p>
-            <a:pPr indent="0" marL="0">
+            <a:pPr marL="0" indent="0">
               <a:buNone/>
             </a:pPr>
             <a:r>
@@ -3719,7 +3683,7 @@
           </a:solidFill>
           <a:ln/>
           <a:effectLst>
-            <a:outerShdw sx="100000" sy="100000" kx="0" ky="0" algn="bl" rotWithShape="0" blurRad="76200" dist="25400" dir="5400000">
+            <a:outerShdw blurRad="76200" dist="25400" dir="5400000" algn="bl" rotWithShape="0">
               <a:srgbClr val="999999">
                 <a:alpha val="35000"/>
               </a:srgbClr>
@@ -3768,7 +3732,7 @@
           <a:bodyPr wrap="square" lIns="0" tIns="0" rIns="0" bIns="0" rtlCol="0" anchor="ctr"/>
           <a:lstStyle/>
           <a:p>
-            <a:pPr algn="ctr" indent="0" marL="0">
+            <a:pPr marL="0" indent="0" algn="ctr">
               <a:buNone/>
             </a:pPr>
             <a:r>
@@ -3807,7 +3771,7 @@
           <a:bodyPr wrap="square" lIns="0" tIns="0" rIns="0" bIns="0" rtlCol="0" anchor="ctr"/>
           <a:lstStyle/>
           <a:p>
-            <a:pPr indent="0" marL="0">
+            <a:pPr marL="0" indent="0">
               <a:buNone/>
             </a:pPr>
             <a:r>
@@ -3846,7 +3810,7 @@
           <a:bodyPr wrap="square" lIns="0" tIns="0" rIns="0" bIns="0" rtlCol="0" anchor="ctr"/>
           <a:lstStyle/>
           <a:p>
-            <a:pPr indent="0" marL="0">
+            <a:pPr marL="0" indent="0">
               <a:buNone/>
             </a:pPr>
             <a:r>
@@ -3885,7 +3849,7 @@
           </a:solidFill>
           <a:ln/>
           <a:effectLst>
-            <a:outerShdw sx="100000" sy="100000" kx="0" ky="0" algn="bl" rotWithShape="0" blurRad="76200" dist="25400" dir="5400000">
+            <a:outerShdw blurRad="76200" dist="25400" dir="5400000" algn="bl" rotWithShape="0">
               <a:srgbClr val="999999">
                 <a:alpha val="35000"/>
               </a:srgbClr>
@@ -3934,7 +3898,7 @@
           <a:bodyPr wrap="square" lIns="0" tIns="0" rIns="0" bIns="0" rtlCol="0" anchor="ctr"/>
           <a:lstStyle/>
           <a:p>
-            <a:pPr algn="ctr" indent="0" marL="0">
+            <a:pPr marL="0" indent="0" algn="ctr">
               <a:buNone/>
             </a:pPr>
             <a:r>
@@ -3973,7 +3937,7 @@
           <a:bodyPr wrap="square" lIns="0" tIns="0" rIns="0" bIns="0" rtlCol="0" anchor="ctr"/>
           <a:lstStyle/>
           <a:p>
-            <a:pPr indent="0" marL="0">
+            <a:pPr marL="0" indent="0">
               <a:buNone/>
             </a:pPr>
             <a:r>
@@ -4012,7 +3976,7 @@
           <a:bodyPr wrap="square" lIns="0" tIns="0" rIns="0" bIns="0" rtlCol="0" anchor="ctr"/>
           <a:lstStyle/>
           <a:p>
-            <a:pPr indent="0" marL="0">
+            <a:pPr marL="0" indent="0">
               <a:buNone/>
             </a:pPr>
             <a:r>
@@ -4051,7 +4015,7 @@
           </a:solidFill>
           <a:ln/>
           <a:effectLst>
-            <a:outerShdw sx="100000" sy="100000" kx="0" ky="0" algn="bl" rotWithShape="0" blurRad="76200" dist="25400" dir="5400000">
+            <a:outerShdw blurRad="76200" dist="25400" dir="5400000" algn="bl" rotWithShape="0">
               <a:srgbClr val="999999">
                 <a:alpha val="35000"/>
               </a:srgbClr>
@@ -4100,7 +4064,7 @@
           <a:bodyPr wrap="square" lIns="0" tIns="0" rIns="0" bIns="0" rtlCol="0" anchor="ctr"/>
           <a:lstStyle/>
           <a:p>
-            <a:pPr algn="ctr" indent="0" marL="0">
+            <a:pPr marL="0" indent="0" algn="ctr">
               <a:buNone/>
             </a:pPr>
             <a:r>
@@ -4139,7 +4103,7 @@
           <a:bodyPr wrap="square" lIns="0" tIns="0" rIns="0" bIns="0" rtlCol="0" anchor="ctr"/>
           <a:lstStyle/>
           <a:p>
-            <a:pPr indent="0" marL="0">
+            <a:pPr marL="0" indent="0">
               <a:buNone/>
             </a:pPr>
             <a:r>
@@ -4178,7 +4142,7 @@
           <a:bodyPr wrap="square" lIns="0" tIns="0" rIns="0" bIns="0" rtlCol="0" anchor="ctr"/>
           <a:lstStyle/>
           <a:p>
-            <a:pPr indent="0" marL="0">
+            <a:pPr marL="0" indent="0">
               <a:buNone/>
             </a:pPr>
             <a:r>
@@ -4212,6 +4176,7 @@
         <a:solidFill>
           <a:srgbClr val="BA0C2F"/>
         </a:solidFill>
+        <a:effectLst/>
       </p:bgPr>
     </p:bg>
     <p:spTree>
@@ -4236,7 +4201,7 @@
         </p:nvSpPr>
         <p:spPr>
           <a:xfrm>
-            <a:off x="731520" y="1188720"/>
+            <a:off x="731520" y="1627839"/>
             <a:ext cx="10725912" cy="1097280"/>
           </a:xfrm>
           <a:prstGeom prst="rect">
@@ -4249,7 +4214,7 @@
           <a:bodyPr wrap="square" rtlCol="0" anchor="ctr"/>
           <a:lstStyle/>
           <a:p>
-            <a:pPr algn="ctr" indent="0" marL="0">
+            <a:pPr marL="0" indent="0" algn="ctr">
               <a:buNone/>
             </a:pPr>
             <a:r>
@@ -4285,24 +4250,19 @@
           <a:ln/>
         </p:spPr>
         <p:txBody>
-          <a:bodyPr wrap="square" rtlCol="0" anchor="ctr"/>
-          <a:lstStyle/>
-          <a:p>
-            <a:pPr algn="ctr" indent="0" marL="0">
-              <a:buNone/>
-            </a:pPr>
-            <a:r>
-              <a:rPr lang="en-US" sz="2000" i="1" dirty="0">
-                <a:solidFill>
-                  <a:srgbClr val="F2C8D0"/>
-                </a:solidFill>
-                <a:latin typeface="Calibri" pitchFamily="34" charset="0"/>
-                <a:ea typeface="Calibri" pitchFamily="34" charset="-122"/>
-                <a:cs typeface="Calibri" pitchFamily="34" charset="-120"/>
-              </a:rPr>
-              <a:t>¿Preguntas?</a:t>
-            </a:r>
-            <a:endParaRPr lang="en-US" sz="2000" dirty="0"/>
+          <a:bodyPr wrap="square" lIns="91440" tIns="45720" rIns="91440" bIns="45720" rtlCol="0" anchor="ctr"/>
+          <a:lstStyle/>
+          <a:p>
+            <a:pPr marL="0" indent="0" algn="ctr">
+              <a:buNone/>
+            </a:pPr>
+            <a:endParaRPr lang="en-US" sz="2000" i="1" dirty="0">
+              <a:solidFill>
+                <a:srgbClr val="F2C8D0"/>
+              </a:solidFill>
+              <a:ea typeface="Calibri"/>
+              <a:cs typeface="Calibri"/>
+            </a:endParaRPr>
           </a:p>
         </p:txBody>
       </p:sp>
@@ -4349,7 +4309,7 @@
           <a:bodyPr wrap="square" lIns="0" tIns="0" rIns="0" bIns="0" rtlCol="0" anchor="ctr"/>
           <a:lstStyle/>
           <a:p>
-            <a:pPr algn="ctr" indent="0" marL="0">
+            <a:pPr marL="0" indent="0" algn="ctr">
               <a:buNone/>
             </a:pPr>
             <a:r>
@@ -4364,9 +4324,6 @@
               <a:t>Todo el proyecto es público y reproducible
 </a:t>
             </a:r>
-            <a:pPr algn="ctr" indent="0" marL="0">
-              <a:buNone/>
-            </a:pPr>
             <a:r>
               <a:rPr lang="en-US" sz="1300" b="1" dirty="0">
                 <a:solidFill>
@@ -4378,9 +4335,6 @@
               </a:rPr>
               <a:t>Código (GitHub, rama main):  </a:t>
             </a:r>
-            <a:pPr algn="ctr" indent="0" marL="0">
-              <a:buNone/>
-            </a:pPr>
             <a:r>
               <a:rPr lang="en-US" sz="1300" dirty="0">
                 <a:solidFill>
@@ -4393,9 +4347,6 @@
               <a:t>github.com/RaulHernandoViadero/validacion_prestamos
 </a:t>
             </a:r>
-            <a:pPr algn="ctr" indent="0" marL="0">
-              <a:buNone/>
-            </a:pPr>
             <a:r>
               <a:rPr lang="en-US" sz="1300" b="1" dirty="0">
                 <a:solidFill>
@@ -4407,9 +4358,6 @@
               </a:rPr>
               <a:t>Memoria, modelos y demos (Drive):  </a:t>
             </a:r>
-            <a:pPr algn="ctr" indent="0" marL="0">
-              <a:buNone/>
-            </a:pPr>
             <a:r>
               <a:rPr lang="en-US" sz="1200" dirty="0">
                 <a:solidFill>
@@ -4446,7 +4394,7 @@
           <a:bodyPr wrap="square" rtlCol="0" anchor="ctr"/>
           <a:lstStyle/>
           <a:p>
-            <a:pPr algn="ctr" indent="0" marL="0">
+            <a:pPr marL="0" indent="0" algn="ctr">
               <a:buNone/>
             </a:pPr>
             <a:r>
@@ -4480,6 +4428,7 @@
         <a:solidFill>
           <a:srgbClr val="FFFFFF"/>
         </a:solidFill>
+        <a:effectLst/>
       </p:bgPr>
     </p:bg>
     <p:spTree>
@@ -4517,7 +4466,7 @@
           <a:bodyPr wrap="square" rtlCol="0" anchor="ctr"/>
           <a:lstStyle/>
           <a:p>
-            <a:pPr indent="0" marL="0">
+            <a:pPr marL="0" indent="0">
               <a:buNone/>
             </a:pPr>
             <a:r>
@@ -4556,7 +4505,7 @@
           <a:bodyPr wrap="square" rtlCol="0" anchor="ctr"/>
           <a:lstStyle/>
           <a:p>
-            <a:pPr indent="0" marL="0">
+            <a:pPr marL="0" indent="0">
               <a:buNone/>
             </a:pPr>
             <a:r>
@@ -4595,7 +4544,7 @@
           </a:solidFill>
           <a:ln/>
           <a:effectLst>
-            <a:outerShdw sx="100000" sy="100000" kx="0" ky="0" algn="bl" rotWithShape="0" blurRad="76200" dist="25400" dir="5400000">
+            <a:outerShdw blurRad="76200" dist="25400" dir="5400000" algn="bl" rotWithShape="0">
               <a:srgbClr val="999999">
                 <a:alpha val="35000"/>
               </a:srgbClr>
@@ -4644,7 +4593,7 @@
           <a:bodyPr wrap="square" lIns="0" tIns="0" rIns="0" bIns="0" rtlCol="0" anchor="ctr"/>
           <a:lstStyle/>
           <a:p>
-            <a:pPr algn="ctr" indent="0" marL="0">
+            <a:pPr marL="0" indent="0" algn="ctr">
               <a:buNone/>
             </a:pPr>
             <a:r>
@@ -4683,7 +4632,7 @@
           <a:bodyPr wrap="square" lIns="0" tIns="0" rIns="0" bIns="0" rtlCol="0" anchor="ctr"/>
           <a:lstStyle/>
           <a:p>
-            <a:pPr indent="0" marL="0">
+            <a:pPr marL="0" indent="0">
               <a:buNone/>
             </a:pPr>
             <a:r>
@@ -4722,7 +4671,7 @@
           <a:bodyPr wrap="square" lIns="0" tIns="0" rIns="0" bIns="0" rtlCol="0" anchor="ctr"/>
           <a:lstStyle/>
           <a:p>
-            <a:pPr indent="0" marL="0">
+            <a:pPr marL="0" indent="0">
               <a:buNone/>
             </a:pPr>
             <a:r>
@@ -4761,7 +4710,7 @@
           </a:solidFill>
           <a:ln/>
           <a:effectLst>
-            <a:outerShdw sx="100000" sy="100000" kx="0" ky="0" algn="bl" rotWithShape="0" blurRad="76200" dist="25400" dir="5400000">
+            <a:outerShdw blurRad="76200" dist="25400" dir="5400000" algn="bl" rotWithShape="0">
               <a:srgbClr val="999999">
                 <a:alpha val="35000"/>
               </a:srgbClr>
@@ -4810,7 +4759,7 @@
           <a:bodyPr wrap="square" lIns="0" tIns="0" rIns="0" bIns="0" rtlCol="0" anchor="ctr"/>
           <a:lstStyle/>
           <a:p>
-            <a:pPr algn="ctr" indent="0" marL="0">
+            <a:pPr marL="0" indent="0" algn="ctr">
               <a:buNone/>
             </a:pPr>
             <a:r>
@@ -4849,7 +4798,7 @@
           <a:bodyPr wrap="square" lIns="0" tIns="0" rIns="0" bIns="0" rtlCol="0" anchor="ctr"/>
           <a:lstStyle/>
           <a:p>
-            <a:pPr indent="0" marL="0">
+            <a:pPr marL="0" indent="0">
               <a:buNone/>
             </a:pPr>
             <a:r>
@@ -4888,7 +4837,7 @@
           <a:bodyPr wrap="square" lIns="0" tIns="0" rIns="0" bIns="0" rtlCol="0" anchor="ctr"/>
           <a:lstStyle/>
           <a:p>
-            <a:pPr indent="0" marL="0">
+            <a:pPr marL="0" indent="0">
               <a:buNone/>
             </a:pPr>
             <a:r>
@@ -4927,7 +4876,7 @@
           </a:solidFill>
           <a:ln/>
           <a:effectLst>
-            <a:outerShdw sx="100000" sy="100000" kx="0" ky="0" algn="bl" rotWithShape="0" blurRad="76200" dist="25400" dir="5400000">
+            <a:outerShdw blurRad="76200" dist="25400" dir="5400000" algn="bl" rotWithShape="0">
               <a:srgbClr val="999999">
                 <a:alpha val="35000"/>
               </a:srgbClr>
@@ -4976,7 +4925,7 @@
           <a:bodyPr wrap="square" lIns="0" tIns="0" rIns="0" bIns="0" rtlCol="0" anchor="ctr"/>
           <a:lstStyle/>
           <a:p>
-            <a:pPr algn="ctr" indent="0" marL="0">
+            <a:pPr marL="0" indent="0" algn="ctr">
               <a:buNone/>
             </a:pPr>
             <a:r>
@@ -5015,7 +4964,7 @@
           <a:bodyPr wrap="square" lIns="0" tIns="0" rIns="0" bIns="0" rtlCol="0" anchor="ctr"/>
           <a:lstStyle/>
           <a:p>
-            <a:pPr indent="0" marL="0">
+            <a:pPr marL="0" indent="0">
               <a:buNone/>
             </a:pPr>
             <a:r>
@@ -5054,7 +5003,7 @@
           <a:bodyPr wrap="square" lIns="0" tIns="0" rIns="0" bIns="0" rtlCol="0" anchor="ctr"/>
           <a:lstStyle/>
           <a:p>
-            <a:pPr indent="0" marL="0">
+            <a:pPr marL="0" indent="0">
               <a:buNone/>
             </a:pPr>
             <a:r>
@@ -5093,7 +5042,7 @@
           <a:bodyPr wrap="square" rtlCol="0" anchor="ctr"/>
           <a:lstStyle/>
           <a:p>
-            <a:pPr algn="ctr" indent="0" marL="0">
+            <a:pPr marL="0" indent="0" algn="ctr">
               <a:buNone/>
             </a:pPr>
             <a:r>
@@ -5127,6 +5076,7 @@
         <a:solidFill>
           <a:srgbClr val="FFFFFF"/>
         </a:solidFill>
+        <a:effectLst/>
       </p:bgPr>
     </p:bg>
     <p:spTree>
@@ -5164,7 +5114,7 @@
           <a:bodyPr wrap="square" rtlCol="0" anchor="ctr"/>
           <a:lstStyle/>
           <a:p>
-            <a:pPr indent="0" marL="0">
+            <a:pPr marL="0" indent="0">
               <a:buNone/>
             </a:pPr>
             <a:r>
@@ -5203,7 +5153,7 @@
           <a:bodyPr wrap="square" rtlCol="0" anchor="ctr"/>
           <a:lstStyle/>
           <a:p>
-            <a:pPr indent="0" marL="0">
+            <a:pPr marL="0" indent="0">
               <a:buNone/>
             </a:pPr>
             <a:r>
@@ -5242,7 +5192,7 @@
           </a:solidFill>
           <a:ln/>
           <a:effectLst>
-            <a:outerShdw sx="100000" sy="100000" kx="0" ky="0" algn="bl" rotWithShape="0" blurRad="76200" dist="25400" dir="5400000">
+            <a:outerShdw blurRad="76200" dist="25400" dir="5400000" algn="bl" rotWithShape="0">
               <a:srgbClr val="999999">
                 <a:alpha val="35000"/>
               </a:srgbClr>
@@ -5271,11 +5221,11 @@
           <a:bodyPr wrap="square" lIns="0" tIns="0" rIns="0" bIns="0" rtlCol="0" anchor="ctr"/>
           <a:lstStyle/>
           <a:p>
-            <a:pPr algn="ctr" indent="0" marL="0">
-              <a:buNone/>
-            </a:pPr>
-            <a:r>
-              <a:rPr lang="en-US" sz="1300" b="1" spc="200" kern="0" dirty="0">
+            <a:pPr marL="0" indent="0" algn="ctr">
+              <a:buNone/>
+            </a:pPr>
+            <a:r>
+              <a:rPr lang="en-US" sz="1300" b="1" kern="0" spc="200" dirty="0">
                 <a:solidFill>
                   <a:srgbClr val="6E6E6E"/>
                 </a:solidFill>
@@ -5310,7 +5260,7 @@
           <a:bodyPr wrap="square" lIns="0" tIns="0" rIns="0" bIns="0" rtlCol="0" anchor="ctr"/>
           <a:lstStyle/>
           <a:p>
-            <a:pPr indent="0" marL="0">
+            <a:pPr marL="0" indent="0">
               <a:buNone/>
             </a:pPr>
             <a:r>
@@ -5327,13 +5277,13 @@
             <a:endParaRPr lang="en-US" sz="1600" dirty="0"/>
           </a:p>
           <a:p>
-            <a:pPr indent="0" marL="0">
+            <a:pPr marL="0" indent="0">
               <a:buNone/>
             </a:pPr>
             <a:endParaRPr lang="en-US" sz="1600" dirty="0"/>
           </a:p>
           <a:p>
-            <a:pPr indent="0" marL="0">
+            <a:pPr marL="0" indent="0">
               <a:buNone/>
             </a:pPr>
             <a:r>
@@ -5392,7 +5342,7 @@
           </a:solidFill>
           <a:ln/>
           <a:effectLst>
-            <a:outerShdw sx="100000" sy="100000" kx="0" ky="0" algn="bl" rotWithShape="0" blurRad="76200" dist="25400" dir="5400000">
+            <a:outerShdw blurRad="76200" dist="25400" dir="5400000" algn="bl" rotWithShape="0">
               <a:srgbClr val="999999">
                 <a:alpha val="35000"/>
               </a:srgbClr>
@@ -5421,11 +5371,11 @@
           <a:bodyPr wrap="square" lIns="0" tIns="0" rIns="0" bIns="0" rtlCol="0" anchor="ctr"/>
           <a:lstStyle/>
           <a:p>
-            <a:pPr algn="ctr" indent="0" marL="0">
-              <a:buNone/>
-            </a:pPr>
-            <a:r>
-              <a:rPr lang="en-US" sz="1300" b="1" spc="200" kern="0" dirty="0">
+            <a:pPr marL="0" indent="0" algn="ctr">
+              <a:buNone/>
+            </a:pPr>
+            <a:r>
+              <a:rPr lang="en-US" sz="1300" b="1" kern="0" spc="200" dirty="0">
                 <a:solidFill>
                   <a:srgbClr val="6E6E6E"/>
                 </a:solidFill>
@@ -5460,7 +5410,7 @@
           <a:bodyPr wrap="square" lIns="0" tIns="0" rIns="0" bIns="0" rtlCol="0" anchor="ctr"/>
           <a:lstStyle/>
           <a:p>
-            <a:pPr indent="0" marL="0">
+            <a:pPr marL="0" indent="0">
               <a:lnSpc>
                 <a:spcPts val="2600"/>
               </a:lnSpc>
@@ -5480,7 +5430,7 @@
             <a:endParaRPr lang="en-US" sz="1450" dirty="0"/>
           </a:p>
           <a:p>
-            <a:pPr indent="0" marL="0">
+            <a:pPr marL="0" indent="0">
               <a:lnSpc>
                 <a:spcPts val="2600"/>
               </a:lnSpc>
@@ -5500,7 +5450,7 @@
             <a:endParaRPr lang="en-US" sz="1450" dirty="0"/>
           </a:p>
           <a:p>
-            <a:pPr indent="0" marL="0">
+            <a:pPr marL="0" indent="0">
               <a:lnSpc>
                 <a:spcPts val="2600"/>
               </a:lnSpc>
@@ -5520,7 +5470,7 @@
             <a:endParaRPr lang="en-US" sz="1450" dirty="0"/>
           </a:p>
           <a:p>
-            <a:pPr indent="0" marL="0">
+            <a:pPr marL="0" indent="0">
               <a:lnSpc>
                 <a:spcPts val="2600"/>
               </a:lnSpc>
@@ -5582,7 +5532,7 @@
           </a:solidFill>
           <a:ln/>
           <a:effectLst>
-            <a:outerShdw sx="100000" sy="100000" kx="0" ky="0" algn="bl" rotWithShape="0" blurRad="76200" dist="25400" dir="5400000">
+            <a:outerShdw blurRad="76200" dist="25400" dir="5400000" algn="bl" rotWithShape="0">
               <a:srgbClr val="999999">
                 <a:alpha val="35000"/>
               </a:srgbClr>
@@ -5611,11 +5561,11 @@
           <a:bodyPr wrap="square" lIns="0" tIns="0" rIns="0" bIns="0" rtlCol="0" anchor="ctr"/>
           <a:lstStyle/>
           <a:p>
-            <a:pPr algn="ctr" indent="0" marL="0">
-              <a:buNone/>
-            </a:pPr>
-            <a:r>
-              <a:rPr lang="en-US" sz="1200" b="1" spc="100" kern="0" dirty="0">
+            <a:pPr marL="0" indent="0" algn="ctr">
+              <a:buNone/>
+            </a:pPr>
+            <a:r>
+              <a:rPr lang="en-US" sz="1200" b="1" kern="0" spc="100" dirty="0">
                 <a:solidFill>
                   <a:srgbClr val="6E6E6E"/>
                 </a:solidFill>
@@ -5650,7 +5600,7 @@
           <a:bodyPr wrap="square" lIns="0" tIns="0" rIns="0" bIns="0" rtlCol="0" anchor="ctr"/>
           <a:lstStyle/>
           <a:p>
-            <a:pPr algn="ctr" indent="0" marL="0">
+            <a:pPr marL="0" indent="0" algn="ctr">
               <a:buNone/>
             </a:pPr>
             <a:r>
@@ -5667,7 +5617,7 @@
             <a:endParaRPr lang="en-US" sz="1600" dirty="0"/>
           </a:p>
           <a:p>
-            <a:pPr algn="ctr" indent="0" marL="0">
+            <a:pPr marL="0" indent="0" algn="ctr">
               <a:buNone/>
             </a:pPr>
             <a:r>
@@ -5706,7 +5656,7 @@
           <a:bodyPr wrap="square" lIns="0" tIns="0" rIns="0" bIns="0" rtlCol="0" anchor="ctr"/>
           <a:lstStyle/>
           <a:p>
-            <a:pPr algn="ctr" indent="0" marL="0">
+            <a:pPr marL="0" indent="0" algn="ctr">
               <a:buNone/>
             </a:pPr>
             <a:r>
@@ -5723,7 +5673,7 @@
             <a:endParaRPr lang="en-US" sz="1300" dirty="0"/>
           </a:p>
           <a:p>
-            <a:pPr algn="ctr" indent="0" marL="0">
+            <a:pPr marL="0" indent="0" algn="ctr">
               <a:buNone/>
             </a:pPr>
             <a:r>
@@ -5762,7 +5712,7 @@
           <a:bodyPr wrap="square" rtlCol="0" anchor="ctr"/>
           <a:lstStyle/>
           <a:p>
-            <a:pPr algn="ctr" indent="0" marL="0">
+            <a:pPr marL="0" indent="0" algn="ctr">
               <a:buNone/>
             </a:pPr>
             <a:r>
@@ -5796,6 +5746,7 @@
         <a:solidFill>
           <a:srgbClr val="FFFFFF"/>
         </a:solidFill>
+        <a:effectLst/>
       </p:bgPr>
     </p:bg>
     <p:spTree>
@@ -5833,7 +5784,7 @@
           <a:bodyPr wrap="square" rtlCol="0" anchor="ctr"/>
           <a:lstStyle/>
           <a:p>
-            <a:pPr indent="0" marL="0">
+            <a:pPr marL="0" indent="0">
               <a:buNone/>
             </a:pPr>
             <a:r>
@@ -5872,7 +5823,7 @@
           <a:bodyPr wrap="square" rtlCol="0" anchor="ctr"/>
           <a:lstStyle/>
           <a:p>
-            <a:pPr indent="0" marL="0">
+            <a:pPr marL="0" indent="0">
               <a:buNone/>
             </a:pPr>
             <a:r>
@@ -5911,7 +5862,7 @@
           </a:solidFill>
           <a:ln/>
           <a:effectLst>
-            <a:outerShdw sx="100000" sy="100000" kx="0" ky="0" algn="bl" rotWithShape="0" blurRad="76200" dist="25400" dir="5400000">
+            <a:outerShdw blurRad="76200" dist="25400" dir="5400000" algn="bl" rotWithShape="0">
               <a:srgbClr val="999999">
                 <a:alpha val="35000"/>
               </a:srgbClr>
@@ -5960,7 +5911,7 @@
           <a:bodyPr wrap="square" lIns="0" tIns="0" rIns="0" bIns="0" rtlCol="0" anchor="ctr"/>
           <a:lstStyle/>
           <a:p>
-            <a:pPr algn="ctr" indent="0" marL="0">
+            <a:pPr marL="0" indent="0" algn="ctr">
               <a:buNone/>
             </a:pPr>
             <a:r>
@@ -5999,7 +5950,7 @@
           <a:bodyPr wrap="square" lIns="0" tIns="0" rIns="0" bIns="0" rtlCol="0" anchor="ctr"/>
           <a:lstStyle/>
           <a:p>
-            <a:pPr indent="0" marL="0">
+            <a:pPr marL="0" indent="0">
               <a:buNone/>
             </a:pPr>
             <a:r>
@@ -6038,7 +5989,7 @@
           <a:bodyPr wrap="square" lIns="0" tIns="0" rIns="0" bIns="0" rtlCol="0" anchor="ctr"/>
           <a:lstStyle/>
           <a:p>
-            <a:pPr indent="0" marL="0">
+            <a:pPr marL="0" indent="0">
               <a:buNone/>
             </a:pPr>
             <a:r>
@@ -6077,7 +6028,7 @@
           </a:solidFill>
           <a:ln/>
           <a:effectLst>
-            <a:outerShdw sx="100000" sy="100000" kx="0" ky="0" algn="bl" rotWithShape="0" blurRad="76200" dist="25400" dir="5400000">
+            <a:outerShdw blurRad="76200" dist="25400" dir="5400000" algn="bl" rotWithShape="0">
               <a:srgbClr val="999999">
                 <a:alpha val="35000"/>
               </a:srgbClr>
@@ -6126,7 +6077,7 @@
           <a:bodyPr wrap="square" lIns="0" tIns="0" rIns="0" bIns="0" rtlCol="0" anchor="ctr"/>
           <a:lstStyle/>
           <a:p>
-            <a:pPr algn="ctr" indent="0" marL="0">
+            <a:pPr marL="0" indent="0" algn="ctr">
               <a:buNone/>
             </a:pPr>
             <a:r>
@@ -6165,7 +6116,7 @@
           <a:bodyPr wrap="square" lIns="0" tIns="0" rIns="0" bIns="0" rtlCol="0" anchor="ctr"/>
           <a:lstStyle/>
           <a:p>
-            <a:pPr indent="0" marL="0">
+            <a:pPr marL="0" indent="0">
               <a:buNone/>
             </a:pPr>
             <a:r>
@@ -6204,7 +6155,7 @@
           <a:bodyPr wrap="square" lIns="0" tIns="0" rIns="0" bIns="0" rtlCol="0" anchor="ctr"/>
           <a:lstStyle/>
           <a:p>
-            <a:pPr indent="0" marL="0">
+            <a:pPr marL="0" indent="0">
               <a:buNone/>
             </a:pPr>
             <a:r>
@@ -6243,7 +6194,7 @@
           </a:solidFill>
           <a:ln/>
           <a:effectLst>
-            <a:outerShdw sx="100000" sy="100000" kx="0" ky="0" algn="bl" rotWithShape="0" blurRad="76200" dist="25400" dir="5400000">
+            <a:outerShdw blurRad="76200" dist="25400" dir="5400000" algn="bl" rotWithShape="0">
               <a:srgbClr val="999999">
                 <a:alpha val="35000"/>
               </a:srgbClr>
@@ -6292,7 +6243,7 @@
           <a:bodyPr wrap="square" lIns="0" tIns="0" rIns="0" bIns="0" rtlCol="0" anchor="ctr"/>
           <a:lstStyle/>
           <a:p>
-            <a:pPr algn="ctr" indent="0" marL="0">
+            <a:pPr marL="0" indent="0" algn="ctr">
               <a:buNone/>
             </a:pPr>
             <a:r>
@@ -6331,7 +6282,7 @@
           <a:bodyPr wrap="square" lIns="0" tIns="0" rIns="0" bIns="0" rtlCol="0" anchor="ctr"/>
           <a:lstStyle/>
           <a:p>
-            <a:pPr indent="0" marL="0">
+            <a:pPr marL="0" indent="0">
               <a:buNone/>
             </a:pPr>
             <a:r>
@@ -6370,7 +6321,7 @@
           <a:bodyPr wrap="square" lIns="0" tIns="0" rIns="0" bIns="0" rtlCol="0" anchor="ctr"/>
           <a:lstStyle/>
           <a:p>
-            <a:pPr indent="0" marL="0">
+            <a:pPr marL="0" indent="0">
               <a:buNone/>
             </a:pPr>
             <a:r>
@@ -6409,7 +6360,7 @@
           </a:solidFill>
           <a:ln/>
           <a:effectLst>
-            <a:outerShdw sx="100000" sy="100000" kx="0" ky="0" algn="bl" rotWithShape="0" blurRad="76200" dist="25400" dir="5400000">
+            <a:outerShdw blurRad="76200" dist="25400" dir="5400000" algn="bl" rotWithShape="0">
               <a:srgbClr val="999999">
                 <a:alpha val="35000"/>
               </a:srgbClr>
@@ -6458,7 +6409,7 @@
           <a:bodyPr wrap="square" lIns="0" tIns="0" rIns="0" bIns="0" rtlCol="0" anchor="ctr"/>
           <a:lstStyle/>
           <a:p>
-            <a:pPr algn="ctr" indent="0" marL="0">
+            <a:pPr marL="0" indent="0" algn="ctr">
               <a:buNone/>
             </a:pPr>
             <a:r>
@@ -6497,7 +6448,7 @@
           <a:bodyPr wrap="square" lIns="0" tIns="0" rIns="0" bIns="0" rtlCol="0" anchor="ctr"/>
           <a:lstStyle/>
           <a:p>
-            <a:pPr indent="0" marL="0">
+            <a:pPr marL="0" indent="0">
               <a:buNone/>
             </a:pPr>
             <a:r>
@@ -6536,7 +6487,7 @@
           <a:bodyPr wrap="square" lIns="0" tIns="0" rIns="0" bIns="0" rtlCol="0" anchor="ctr"/>
           <a:lstStyle/>
           <a:p>
-            <a:pPr indent="0" marL="0">
+            <a:pPr marL="0" indent="0">
               <a:buNone/>
             </a:pPr>
             <a:r>
@@ -6575,7 +6526,7 @@
           </a:solidFill>
           <a:ln/>
           <a:effectLst>
-            <a:outerShdw sx="100000" sy="100000" kx="0" ky="0" algn="bl" rotWithShape="0" blurRad="76200" dist="25400" dir="5400000">
+            <a:outerShdw blurRad="76200" dist="25400" dir="5400000" algn="bl" rotWithShape="0">
               <a:srgbClr val="999999">
                 <a:alpha val="35000"/>
               </a:srgbClr>
@@ -6624,7 +6575,7 @@
           <a:bodyPr wrap="square" lIns="0" tIns="0" rIns="0" bIns="0" rtlCol="0" anchor="ctr"/>
           <a:lstStyle/>
           <a:p>
-            <a:pPr algn="ctr" indent="0" marL="0">
+            <a:pPr marL="0" indent="0" algn="ctr">
               <a:buNone/>
             </a:pPr>
             <a:r>
@@ -6663,7 +6614,7 @@
           <a:bodyPr wrap="square" lIns="0" tIns="0" rIns="0" bIns="0" rtlCol="0" anchor="ctr"/>
           <a:lstStyle/>
           <a:p>
-            <a:pPr indent="0" marL="0">
+            <a:pPr marL="0" indent="0">
               <a:buNone/>
             </a:pPr>
             <a:r>
@@ -6702,7 +6653,7 @@
           <a:bodyPr wrap="square" lIns="0" tIns="0" rIns="0" bIns="0" rtlCol="0" anchor="ctr"/>
           <a:lstStyle/>
           <a:p>
-            <a:pPr indent="0" marL="0">
+            <a:pPr marL="0" indent="0">
               <a:buNone/>
             </a:pPr>
             <a:r>
@@ -6741,7 +6692,7 @@
           </a:solidFill>
           <a:ln/>
           <a:effectLst>
-            <a:outerShdw sx="100000" sy="100000" kx="0" ky="0" algn="bl" rotWithShape="0" blurRad="76200" dist="25400" dir="5400000">
+            <a:outerShdw blurRad="76200" dist="25400" dir="5400000" algn="bl" rotWithShape="0">
               <a:srgbClr val="999999">
                 <a:alpha val="35000"/>
               </a:srgbClr>
@@ -6790,7 +6741,7 @@
           <a:bodyPr wrap="square" lIns="0" tIns="0" rIns="0" bIns="0" rtlCol="0" anchor="ctr"/>
           <a:lstStyle/>
           <a:p>
-            <a:pPr algn="ctr" indent="0" marL="0">
+            <a:pPr marL="0" indent="0" algn="ctr">
               <a:buNone/>
             </a:pPr>
             <a:r>
@@ -6829,7 +6780,7 @@
           <a:bodyPr wrap="square" lIns="0" tIns="0" rIns="0" bIns="0" rtlCol="0" anchor="ctr"/>
           <a:lstStyle/>
           <a:p>
-            <a:pPr indent="0" marL="0">
+            <a:pPr marL="0" indent="0">
               <a:buNone/>
             </a:pPr>
             <a:r>
@@ -6868,7 +6819,7 @@
           <a:bodyPr wrap="square" lIns="0" tIns="0" rIns="0" bIns="0" rtlCol="0" anchor="ctr"/>
           <a:lstStyle/>
           <a:p>
-            <a:pPr indent="0" marL="0">
+            <a:pPr marL="0" indent="0">
               <a:buNone/>
             </a:pPr>
             <a:r>
@@ -6902,6 +6853,7 @@
         <a:solidFill>
           <a:srgbClr val="FFFFFF"/>
         </a:solidFill>
+        <a:effectLst/>
       </p:bgPr>
     </p:bg>
     <p:spTree>
@@ -6939,7 +6891,7 @@
           <a:bodyPr wrap="square" rtlCol="0" anchor="ctr"/>
           <a:lstStyle/>
           <a:p>
-            <a:pPr indent="0" marL="0">
+            <a:pPr marL="0" indent="0">
               <a:buNone/>
             </a:pPr>
             <a:r>
@@ -6978,7 +6930,7 @@
           <a:bodyPr wrap="square" rtlCol="0" anchor="ctr"/>
           <a:lstStyle/>
           <a:p>
-            <a:pPr indent="0" marL="0">
+            <a:pPr marL="0" indent="0">
               <a:buNone/>
             </a:pPr>
             <a:r>
@@ -7017,7 +6969,7 @@
           <a:bodyPr wrap="square" rtlCol="0" anchor="ctr"/>
           <a:lstStyle/>
           <a:p>
-            <a:pPr indent="0" marL="0">
+            <a:pPr marL="0" indent="0">
               <a:buNone/>
             </a:pPr>
             <a:r>
@@ -7056,7 +7008,7 @@
           <a:bodyPr wrap="square" lIns="0" tIns="0" rIns="0" bIns="0" rtlCol="0" anchor="ctr"/>
           <a:lstStyle/>
           <a:p>
-            <a:pPr algn="ctr" indent="0" marL="0">
+            <a:pPr marL="0" indent="0" algn="ctr">
               <a:buNone/>
             </a:pPr>
             <a:r>
@@ -7095,7 +7047,7 @@
           <a:bodyPr wrap="square" lIns="0" tIns="0" rIns="0" bIns="0" rtlCol="0" anchor="ctr"/>
           <a:lstStyle/>
           <a:p>
-            <a:pPr algn="ctr" indent="0" marL="0">
+            <a:pPr marL="0" indent="0" algn="ctr">
               <a:buNone/>
             </a:pPr>
             <a:r>
@@ -7112,7 +7064,7 @@
             <a:endParaRPr lang="en-US" sz="1300" dirty="0"/>
           </a:p>
           <a:p>
-            <a:pPr algn="ctr" indent="0" marL="0">
+            <a:pPr marL="0" indent="0" algn="ctr">
               <a:buNone/>
             </a:pPr>
             <a:r>
@@ -7151,7 +7103,7 @@
           <a:bodyPr wrap="square" lIns="0" tIns="0" rIns="0" bIns="0" rtlCol="0" anchor="ctr"/>
           <a:lstStyle/>
           <a:p>
-            <a:pPr algn="ctr" indent="0" marL="0">
+            <a:pPr marL="0" indent="0" algn="ctr">
               <a:buNone/>
             </a:pPr>
             <a:r>
@@ -7190,7 +7142,7 @@
           <a:bodyPr wrap="square" lIns="0" tIns="0" rIns="0" bIns="0" rtlCol="0" anchor="ctr"/>
           <a:lstStyle/>
           <a:p>
-            <a:pPr algn="ctr" indent="0" marL="0">
+            <a:pPr marL="0" indent="0" algn="ctr">
               <a:buNone/>
             </a:pPr>
             <a:r>
@@ -7207,7 +7159,7 @@
             <a:endParaRPr lang="en-US" sz="1300" dirty="0"/>
           </a:p>
           <a:p>
-            <a:pPr algn="ctr" indent="0" marL="0">
+            <a:pPr marL="0" indent="0" algn="ctr">
               <a:buNone/>
             </a:pPr>
             <a:r>
@@ -7246,7 +7198,7 @@
           <a:bodyPr wrap="square" lIns="0" tIns="0" rIns="0" bIns="0" rtlCol="0" anchor="ctr"/>
           <a:lstStyle/>
           <a:p>
-            <a:pPr algn="ctr" indent="0" marL="0">
+            <a:pPr marL="0" indent="0" algn="ctr">
               <a:buNone/>
             </a:pPr>
             <a:r>
@@ -7285,7 +7237,7 @@
           <a:bodyPr wrap="square" lIns="0" tIns="0" rIns="0" bIns="0" rtlCol="0" anchor="ctr"/>
           <a:lstStyle/>
           <a:p>
-            <a:pPr algn="ctr" indent="0" marL="0">
+            <a:pPr marL="0" indent="0" algn="ctr">
               <a:buNone/>
             </a:pPr>
             <a:r>
@@ -7302,7 +7254,7 @@
             <a:endParaRPr lang="en-US" sz="1300" dirty="0"/>
           </a:p>
           <a:p>
-            <a:pPr algn="ctr" indent="0" marL="0">
+            <a:pPr marL="0" indent="0" algn="ctr">
               <a:buNone/>
             </a:pPr>
             <a:r>
@@ -7341,7 +7293,7 @@
           <a:bodyPr wrap="square" lIns="0" tIns="0" rIns="0" bIns="0" rtlCol="0" anchor="ctr"/>
           <a:lstStyle/>
           <a:p>
-            <a:pPr algn="ctr" indent="0" marL="0">
+            <a:pPr marL="0" indent="0" algn="ctr">
               <a:buNone/>
             </a:pPr>
             <a:r>
@@ -7380,7 +7332,7 @@
           <a:bodyPr wrap="square" lIns="0" tIns="0" rIns="0" bIns="0" rtlCol="0" anchor="ctr"/>
           <a:lstStyle/>
           <a:p>
-            <a:pPr algn="ctr" indent="0" marL="0">
+            <a:pPr marL="0" indent="0" algn="ctr">
               <a:buNone/>
             </a:pPr>
             <a:r>
@@ -7397,7 +7349,7 @@
             <a:endParaRPr lang="en-US" sz="1300" dirty="0"/>
           </a:p>
           <a:p>
-            <a:pPr algn="ctr" indent="0" marL="0">
+            <a:pPr marL="0" indent="0" algn="ctr">
               <a:buNone/>
             </a:pPr>
             <a:r>
@@ -7436,7 +7388,7 @@
           </a:solidFill>
           <a:ln/>
           <a:effectLst>
-            <a:outerShdw sx="100000" sy="100000" kx="0" ky="0" algn="bl" rotWithShape="0" blurRad="76200" dist="25400" dir="5400000">
+            <a:outerShdw blurRad="76200" dist="25400" dir="5400000" algn="bl" rotWithShape="0">
               <a:srgbClr val="999999">
                 <a:alpha val="35000"/>
               </a:srgbClr>
@@ -7465,7 +7417,7 @@
           <a:bodyPr wrap="square" lIns="0" tIns="0" rIns="0" bIns="0" rtlCol="0" anchor="ctr"/>
           <a:lstStyle/>
           <a:p>
-            <a:pPr indent="0" marL="0">
+            <a:pPr marL="0" indent="0">
               <a:buNone/>
             </a:pPr>
             <a:r>
@@ -7479,9 +7431,6 @@
               </a:rPr>
               <a:t>El detalle importa: </a:t>
             </a:r>
-            <a:pPr indent="0" marL="0">
-              <a:buNone/>
-            </a:pPr>
             <a:r>
               <a:rPr lang="en-US" sz="1400" dirty="0">
                 <a:solidFill>
@@ -7513,6 +7462,7 @@
         <a:solidFill>
           <a:srgbClr val="FFFFFF"/>
         </a:solidFill>
+        <a:effectLst/>
       </p:bgPr>
     </p:bg>
     <p:spTree>
@@ -7550,7 +7500,7 @@
           <a:bodyPr wrap="square" rtlCol="0" anchor="ctr"/>
           <a:lstStyle/>
           <a:p>
-            <a:pPr indent="0" marL="0">
+            <a:pPr marL="0" indent="0">
               <a:buNone/>
             </a:pPr>
             <a:r>
@@ -7589,7 +7539,7 @@
           <a:bodyPr wrap="square" rtlCol="0" anchor="ctr"/>
           <a:lstStyle/>
           <a:p>
-            <a:pPr indent="0" marL="0">
+            <a:pPr marL="0" indent="0">
               <a:buNone/>
             </a:pPr>
             <a:r>
@@ -7628,7 +7578,7 @@
           </a:solidFill>
           <a:ln/>
           <a:effectLst>
-            <a:outerShdw sx="100000" sy="100000" kx="0" ky="0" algn="bl" rotWithShape="0" blurRad="76200" dist="25400" dir="5400000">
+            <a:outerShdw blurRad="76200" dist="25400" dir="5400000" algn="bl" rotWithShape="0">
               <a:srgbClr val="999999">
                 <a:alpha val="35000"/>
               </a:srgbClr>
@@ -7657,7 +7607,7 @@
           <a:bodyPr wrap="square" lIns="0" tIns="0" rIns="0" bIns="0" rtlCol="0" anchor="ctr"/>
           <a:lstStyle/>
           <a:p>
-            <a:pPr indent="0" marL="0">
+            <a:pPr marL="0" indent="0">
               <a:buNone/>
             </a:pPr>
             <a:r>
@@ -7696,7 +7646,7 @@
           <a:bodyPr wrap="square" lIns="0" tIns="0" rIns="0" bIns="0" rtlCol="0" anchor="ctr"/>
           <a:lstStyle/>
           <a:p>
-            <a:pPr indent="0" marL="0">
+            <a:pPr marL="0" indent="0">
               <a:buNone/>
             </a:pPr>
             <a:r>
@@ -7735,7 +7685,7 @@
           <a:bodyPr wrap="square" lIns="0" tIns="0" rIns="0" bIns="0" rtlCol="0" anchor="ctr"/>
           <a:lstStyle/>
           <a:p>
-            <a:pPr algn="ctr" indent="0" marL="0">
+            <a:pPr marL="0" indent="0" algn="ctr">
               <a:buNone/>
             </a:pPr>
             <a:r>
@@ -7774,7 +7724,7 @@
           <a:bodyPr wrap="square" lIns="0" tIns="0" rIns="0" bIns="0" rtlCol="0" anchor="ctr"/>
           <a:lstStyle/>
           <a:p>
-            <a:pPr algn="ctr" indent="0" marL="0">
+            <a:pPr marL="0" indent="0" algn="ctr">
               <a:buNone/>
             </a:pPr>
             <a:r>
@@ -7813,7 +7763,7 @@
           </a:solidFill>
           <a:ln/>
           <a:effectLst>
-            <a:outerShdw sx="100000" sy="100000" kx="0" ky="0" algn="bl" rotWithShape="0" blurRad="76200" dist="25400" dir="5400000">
+            <a:outerShdw blurRad="76200" dist="25400" dir="5400000" algn="bl" rotWithShape="0">
               <a:srgbClr val="999999">
                 <a:alpha val="35000"/>
               </a:srgbClr>
@@ -7842,7 +7792,7 @@
           <a:bodyPr wrap="square" lIns="0" tIns="0" rIns="0" bIns="0" rtlCol="0" anchor="ctr"/>
           <a:lstStyle/>
           <a:p>
-            <a:pPr indent="0" marL="0">
+            <a:pPr marL="0" indent="0">
               <a:buNone/>
             </a:pPr>
             <a:r>
@@ -7881,7 +7831,7 @@
           <a:bodyPr wrap="square" lIns="0" tIns="0" rIns="0" bIns="0" rtlCol="0" anchor="ctr"/>
           <a:lstStyle/>
           <a:p>
-            <a:pPr indent="0" marL="0">
+            <a:pPr marL="0" indent="0">
               <a:buNone/>
             </a:pPr>
             <a:r>
@@ -7920,7 +7870,7 @@
           <a:bodyPr wrap="square" lIns="0" tIns="0" rIns="0" bIns="0" rtlCol="0" anchor="ctr"/>
           <a:lstStyle/>
           <a:p>
-            <a:pPr indent="0" marL="0">
+            <a:pPr marL="0" indent="0">
               <a:buNone/>
             </a:pPr>
             <a:r>
@@ -7959,7 +7909,7 @@
           <a:bodyPr wrap="square" lIns="0" tIns="0" rIns="0" bIns="0" rtlCol="0" anchor="ctr"/>
           <a:lstStyle/>
           <a:p>
-            <a:pPr indent="0" marL="0">
+            <a:pPr marL="0" indent="0">
               <a:buNone/>
             </a:pPr>
             <a:r>
@@ -7998,7 +7948,7 @@
           <a:bodyPr wrap="square" lIns="0" tIns="0" rIns="0" bIns="0" rtlCol="0" anchor="ctr"/>
           <a:lstStyle/>
           <a:p>
-            <a:pPr indent="0" marL="0">
+            <a:pPr marL="0" indent="0">
               <a:buNone/>
             </a:pPr>
             <a:r>
@@ -8037,7 +7987,7 @@
           <a:bodyPr wrap="square" lIns="0" tIns="0" rIns="0" bIns="0" rtlCol="0" anchor="ctr"/>
           <a:lstStyle/>
           <a:p>
-            <a:pPr indent="0" marL="0">
+            <a:pPr marL="0" indent="0">
               <a:buNone/>
             </a:pPr>
             <a:r>
@@ -8076,7 +8026,7 @@
           <a:bodyPr wrap="square" lIns="0" tIns="0" rIns="0" bIns="0" rtlCol="0" anchor="ctr"/>
           <a:lstStyle/>
           <a:p>
-            <a:pPr indent="0" marL="0">
+            <a:pPr marL="0" indent="0">
               <a:buNone/>
             </a:pPr>
             <a:r>
@@ -8115,7 +8065,7 @@
           <a:bodyPr wrap="square" lIns="0" tIns="0" rIns="0" bIns="0" rtlCol="0" anchor="ctr"/>
           <a:lstStyle/>
           <a:p>
-            <a:pPr indent="0" marL="0">
+            <a:pPr marL="0" indent="0">
               <a:buNone/>
             </a:pPr>
             <a:r>
@@ -8154,7 +8104,7 @@
           <a:bodyPr wrap="square" lIns="0" tIns="0" rIns="0" bIns="0" rtlCol="0" anchor="ctr"/>
           <a:lstStyle/>
           <a:p>
-            <a:pPr indent="0" marL="0">
+            <a:pPr marL="0" indent="0">
               <a:buNone/>
             </a:pPr>
             <a:r>
@@ -8193,7 +8143,7 @@
           <a:bodyPr wrap="square" lIns="0" tIns="0" rIns="0" bIns="0" rtlCol="0" anchor="ctr"/>
           <a:lstStyle/>
           <a:p>
-            <a:pPr indent="0" marL="0">
+            <a:pPr marL="0" indent="0">
               <a:buNone/>
             </a:pPr>
             <a:r>
@@ -8232,7 +8182,7 @@
           <a:bodyPr wrap="square" lIns="0" tIns="0" rIns="0" bIns="0" rtlCol="0" anchor="ctr"/>
           <a:lstStyle/>
           <a:p>
-            <a:pPr indent="0" marL="0">
+            <a:pPr marL="0" indent="0">
               <a:buNone/>
             </a:pPr>
             <a:r>
@@ -8271,7 +8221,7 @@
           <a:bodyPr wrap="square" lIns="0" tIns="0" rIns="0" bIns="0" rtlCol="0" anchor="ctr"/>
           <a:lstStyle/>
           <a:p>
-            <a:pPr indent="0" marL="0">
+            <a:pPr marL="0" indent="0">
               <a:buNone/>
             </a:pPr>
             <a:r>
@@ -8310,7 +8260,7 @@
           <a:bodyPr wrap="square" lIns="0" tIns="0" rIns="0" bIns="0" rtlCol="0" anchor="ctr"/>
           <a:lstStyle/>
           <a:p>
-            <a:pPr indent="0" marL="0">
+            <a:pPr marL="0" indent="0">
               <a:buNone/>
             </a:pPr>
             <a:r>
@@ -8349,7 +8299,7 @@
           <a:bodyPr wrap="square" lIns="0" tIns="0" rIns="0" bIns="0" rtlCol="0" anchor="ctr"/>
           <a:lstStyle/>
           <a:p>
-            <a:pPr indent="0" marL="0">
+            <a:pPr marL="0" indent="0">
               <a:buNone/>
             </a:pPr>
             <a:r>
@@ -8388,7 +8338,7 @@
           <a:bodyPr wrap="square" lIns="0" tIns="0" rIns="0" bIns="0" rtlCol="0" anchor="ctr"/>
           <a:lstStyle/>
           <a:p>
-            <a:pPr indent="0" marL="0">
+            <a:pPr marL="0" indent="0">
               <a:buNone/>
             </a:pPr>
             <a:r>
@@ -8427,7 +8377,7 @@
           <a:bodyPr wrap="square" lIns="0" tIns="0" rIns="0" bIns="0" rtlCol="0" anchor="ctr"/>
           <a:lstStyle/>
           <a:p>
-            <a:pPr indent="0" marL="0">
+            <a:pPr marL="0" indent="0">
               <a:buNone/>
             </a:pPr>
             <a:r>
@@ -8466,7 +8416,7 @@
           <a:bodyPr wrap="square" lIns="0" tIns="0" rIns="0" bIns="0" rtlCol="0" anchor="ctr"/>
           <a:lstStyle/>
           <a:p>
-            <a:pPr indent="0" marL="0">
+            <a:pPr marL="0" indent="0">
               <a:buNone/>
             </a:pPr>
             <a:r>
@@ -8500,6 +8450,7 @@
         <a:solidFill>
           <a:srgbClr val="FFFFFF"/>
         </a:solidFill>
+        <a:effectLst/>
       </p:bgPr>
     </p:bg>
     <p:spTree>
@@ -8537,7 +8488,7 @@
           <a:bodyPr wrap="square" rtlCol="0" anchor="ctr"/>
           <a:lstStyle/>
           <a:p>
-            <a:pPr indent="0" marL="0">
+            <a:pPr marL="0" indent="0">
               <a:buNone/>
             </a:pPr>
             <a:r>
@@ -8576,7 +8527,7 @@
           <a:bodyPr wrap="square" rtlCol="0" anchor="ctr"/>
           <a:lstStyle/>
           <a:p>
-            <a:pPr indent="0" marL="0">
+            <a:pPr marL="0" indent="0">
               <a:buNone/>
             </a:pPr>
             <a:r>
@@ -8659,7 +8610,7 @@
           <a:bodyPr wrap="square" lIns="0" tIns="0" rIns="0" bIns="0" rtlCol="0" anchor="ctr"/>
           <a:lstStyle/>
           <a:p>
-            <a:pPr algn="ctr" indent="0" marL="0">
+            <a:pPr marL="0" indent="0" algn="ctr">
               <a:buNone/>
             </a:pPr>
             <a:r>
@@ -8698,7 +8649,7 @@
           <a:bodyPr wrap="square" lIns="0" tIns="0" rIns="0" bIns="0" rtlCol="0" anchor="ctr"/>
           <a:lstStyle/>
           <a:p>
-            <a:pPr indent="0" marL="0">
+            <a:pPr marL="0" indent="0">
               <a:buNone/>
             </a:pPr>
             <a:r>
@@ -8781,7 +8732,7 @@
           <a:bodyPr wrap="square" lIns="0" tIns="0" rIns="0" bIns="0" rtlCol="0" anchor="ctr"/>
           <a:lstStyle/>
           <a:p>
-            <a:pPr algn="ctr" indent="0" marL="0">
+            <a:pPr marL="0" indent="0" algn="ctr">
               <a:buNone/>
             </a:pPr>
             <a:r>
@@ -8820,7 +8771,7 @@
           <a:bodyPr wrap="square" lIns="0" tIns="0" rIns="0" bIns="0" rtlCol="0" anchor="ctr"/>
           <a:lstStyle/>
           <a:p>
-            <a:pPr indent="0" marL="0">
+            <a:pPr marL="0" indent="0">
               <a:buNone/>
             </a:pPr>
             <a:r>
@@ -8903,7 +8854,7 @@
           <a:bodyPr wrap="square" lIns="0" tIns="0" rIns="0" bIns="0" rtlCol="0" anchor="ctr"/>
           <a:lstStyle/>
           <a:p>
-            <a:pPr algn="ctr" indent="0" marL="0">
+            <a:pPr marL="0" indent="0" algn="ctr">
               <a:buNone/>
             </a:pPr>
             <a:r>
@@ -8942,7 +8893,7 @@
           <a:bodyPr wrap="square" lIns="0" tIns="0" rIns="0" bIns="0" rtlCol="0" anchor="ctr"/>
           <a:lstStyle/>
           <a:p>
-            <a:pPr indent="0" marL="0">
+            <a:pPr marL="0" indent="0">
               <a:buNone/>
             </a:pPr>
             <a:r>
@@ -9025,7 +8976,7 @@
           <a:bodyPr wrap="square" lIns="0" tIns="0" rIns="0" bIns="0" rtlCol="0" anchor="ctr"/>
           <a:lstStyle/>
           <a:p>
-            <a:pPr algn="ctr" indent="0" marL="0">
+            <a:pPr marL="0" indent="0" algn="ctr">
               <a:buNone/>
             </a:pPr>
             <a:r>
@@ -9064,7 +9015,7 @@
           <a:bodyPr wrap="square" lIns="0" tIns="0" rIns="0" bIns="0" rtlCol="0" anchor="ctr"/>
           <a:lstStyle/>
           <a:p>
-            <a:pPr indent="0" marL="0">
+            <a:pPr marL="0" indent="0">
               <a:buNone/>
             </a:pPr>
             <a:r>
@@ -9147,7 +9098,7 @@
           <a:bodyPr wrap="square" lIns="0" tIns="0" rIns="0" bIns="0" rtlCol="0" anchor="ctr"/>
           <a:lstStyle/>
           <a:p>
-            <a:pPr algn="ctr" indent="0" marL="0">
+            <a:pPr marL="0" indent="0" algn="ctr">
               <a:buNone/>
             </a:pPr>
             <a:r>
@@ -9186,7 +9137,7 @@
           <a:bodyPr wrap="square" lIns="0" tIns="0" rIns="0" bIns="0" rtlCol="0" anchor="ctr"/>
           <a:lstStyle/>
           <a:p>
-            <a:pPr indent="0" marL="0">
+            <a:pPr marL="0" indent="0">
               <a:buNone/>
             </a:pPr>
             <a:r>
@@ -9269,7 +9220,7 @@
           <a:bodyPr wrap="square" lIns="0" tIns="0" rIns="0" bIns="0" rtlCol="0" anchor="ctr"/>
           <a:lstStyle/>
           <a:p>
-            <a:pPr algn="ctr" indent="0" marL="0">
+            <a:pPr marL="0" indent="0" algn="ctr">
               <a:buNone/>
             </a:pPr>
             <a:r>
@@ -9308,7 +9259,7 @@
           <a:bodyPr wrap="square" lIns="0" tIns="0" rIns="0" bIns="0" rtlCol="0" anchor="ctr"/>
           <a:lstStyle/>
           <a:p>
-            <a:pPr indent="0" marL="0">
+            <a:pPr marL="0" indent="0">
               <a:buNone/>
             </a:pPr>
             <a:r>
@@ -9391,7 +9342,7 @@
           <a:bodyPr wrap="square" lIns="0" tIns="0" rIns="0" bIns="0" rtlCol="0" anchor="ctr"/>
           <a:lstStyle/>
           <a:p>
-            <a:pPr algn="ctr" indent="0" marL="0">
+            <a:pPr marL="0" indent="0" algn="ctr">
               <a:buNone/>
             </a:pPr>
             <a:r>
@@ -9430,7 +9381,7 @@
           <a:bodyPr wrap="square" lIns="0" tIns="0" rIns="0" bIns="0" rtlCol="0" anchor="ctr"/>
           <a:lstStyle/>
           <a:p>
-            <a:pPr indent="0" marL="0">
+            <a:pPr marL="0" indent="0">
               <a:buNone/>
             </a:pPr>
             <a:r>
@@ -9513,7 +9464,7 @@
           <a:bodyPr wrap="square" lIns="0" tIns="0" rIns="0" bIns="0" rtlCol="0" anchor="ctr"/>
           <a:lstStyle/>
           <a:p>
-            <a:pPr algn="ctr" indent="0" marL="0">
+            <a:pPr marL="0" indent="0" algn="ctr">
               <a:buNone/>
             </a:pPr>
             <a:r>
@@ -9552,7 +9503,7 @@
           <a:bodyPr wrap="square" lIns="0" tIns="0" rIns="0" bIns="0" rtlCol="0" anchor="ctr"/>
           <a:lstStyle/>
           <a:p>
-            <a:pPr indent="0" marL="0">
+            <a:pPr marL="0" indent="0">
               <a:buNone/>
             </a:pPr>
             <a:r>
@@ -9591,7 +9542,7 @@
           <a:bodyPr wrap="square" rtlCol="0" anchor="ctr"/>
           <a:lstStyle/>
           <a:p>
-            <a:pPr algn="ctr" indent="0" marL="0">
+            <a:pPr marL="0" indent="0" algn="ctr">
               <a:buNone/>
             </a:pPr>
             <a:r>
@@ -9625,6 +9576,7 @@
         <a:solidFill>
           <a:srgbClr val="FFFFFF"/>
         </a:solidFill>
+        <a:effectLst/>
       </p:bgPr>
     </p:bg>
     <p:spTree>
@@ -9662,7 +9614,7 @@
           <a:bodyPr wrap="square" rtlCol="0" anchor="ctr"/>
           <a:lstStyle/>
           <a:p>
-            <a:pPr indent="0" marL="0">
+            <a:pPr marL="0" indent="0">
               <a:buNone/>
             </a:pPr>
             <a:r>
@@ -9701,7 +9653,7 @@
           <a:bodyPr wrap="square" rtlCol="0" anchor="ctr"/>
           <a:lstStyle/>
           <a:p>
-            <a:pPr indent="0" marL="0">
+            <a:pPr marL="0" indent="0">
               <a:buNone/>
             </a:pPr>
             <a:r>
@@ -9740,7 +9692,7 @@
           </a:solidFill>
           <a:ln/>
           <a:effectLst>
-            <a:outerShdw sx="100000" sy="100000" kx="0" ky="0" algn="bl" rotWithShape="0" blurRad="76200" dist="25400" dir="5400000">
+            <a:outerShdw blurRad="76200" dist="25400" dir="5400000" algn="bl" rotWithShape="0">
               <a:srgbClr val="999999">
                 <a:alpha val="35000"/>
               </a:srgbClr>
@@ -9789,7 +9741,7 @@
           <a:bodyPr wrap="square" lIns="0" tIns="0" rIns="0" bIns="0" rtlCol="0" anchor="ctr"/>
           <a:lstStyle/>
           <a:p>
-            <a:pPr algn="ctr" indent="0" marL="0">
+            <a:pPr marL="0" indent="0" algn="ctr">
               <a:buNone/>
             </a:pPr>
             <a:r>
@@ -9828,7 +9780,7 @@
           <a:bodyPr wrap="square" lIns="0" tIns="0" rIns="0" bIns="0" rtlCol="0" anchor="ctr"/>
           <a:lstStyle/>
           <a:p>
-            <a:pPr indent="0" marL="0">
+            <a:pPr marL="0" indent="0">
               <a:buNone/>
             </a:pPr>
             <a:r>
@@ -9867,7 +9819,7 @@
           <a:bodyPr wrap="square" lIns="0" tIns="0" rIns="0" bIns="0" rtlCol="0" anchor="ctr"/>
           <a:lstStyle/>
           <a:p>
-            <a:pPr indent="0" marL="0">
+            <a:pPr marL="0" indent="0">
               <a:buNone/>
             </a:pPr>
             <a:r>
@@ -9926,7 +9878,7 @@
           <a:bodyPr wrap="square" lIns="0" tIns="0" rIns="0" bIns="0" rtlCol="0" anchor="ctr"/>
           <a:lstStyle/>
           <a:p>
-            <a:pPr algn="ctr" indent="0" marL="0">
+            <a:pPr marL="0" indent="0" algn="ctr">
               <a:buNone/>
             </a:pPr>
             <a:r>
@@ -9965,7 +9917,7 @@
           <a:bodyPr wrap="square" lIns="0" tIns="0" rIns="0" bIns="0" rtlCol="0" anchor="ctr"/>
           <a:lstStyle/>
           <a:p>
-            <a:pPr indent="0" marL="0">
+            <a:pPr marL="0" indent="0">
               <a:buNone/>
             </a:pPr>
             <a:r>
@@ -10004,7 +9956,7 @@
           <a:bodyPr wrap="square" lIns="0" tIns="0" rIns="0" bIns="0" rtlCol="0" anchor="ctr"/>
           <a:lstStyle/>
           <a:p>
-            <a:pPr indent="0" marL="0">
+            <a:pPr marL="0" indent="0">
               <a:buNone/>
             </a:pPr>
             <a:r>
@@ -10063,7 +10015,7 @@
           <a:bodyPr wrap="square" lIns="0" tIns="0" rIns="0" bIns="0" rtlCol="0" anchor="ctr"/>
           <a:lstStyle/>
           <a:p>
-            <a:pPr algn="ctr" indent="0" marL="0">
+            <a:pPr marL="0" indent="0" algn="ctr">
               <a:buNone/>
             </a:pPr>
             <a:r>
@@ -10102,7 +10054,7 @@
           <a:bodyPr wrap="square" lIns="0" tIns="0" rIns="0" bIns="0" rtlCol="0" anchor="ctr"/>
           <a:lstStyle/>
           <a:p>
-            <a:pPr indent="0" marL="0">
+            <a:pPr marL="0" indent="0">
               <a:buNone/>
             </a:pPr>
             <a:r>
@@ -10141,7 +10093,7 @@
           <a:bodyPr wrap="square" lIns="0" tIns="0" rIns="0" bIns="0" rtlCol="0" anchor="ctr"/>
           <a:lstStyle/>
           <a:p>
-            <a:pPr indent="0" marL="0">
+            <a:pPr marL="0" indent="0">
               <a:buNone/>
             </a:pPr>
             <a:r>
@@ -10200,7 +10152,7 @@
           <a:bodyPr wrap="square" lIns="0" tIns="0" rIns="0" bIns="0" rtlCol="0" anchor="ctr"/>
           <a:lstStyle/>
           <a:p>
-            <a:pPr algn="ctr" indent="0" marL="0">
+            <a:pPr marL="0" indent="0" algn="ctr">
               <a:buNone/>
             </a:pPr>
             <a:r>
@@ -10239,7 +10191,7 @@
           <a:bodyPr wrap="square" lIns="0" tIns="0" rIns="0" bIns="0" rtlCol="0" anchor="ctr"/>
           <a:lstStyle/>
           <a:p>
-            <a:pPr indent="0" marL="0">
+            <a:pPr marL="0" indent="0">
               <a:buNone/>
             </a:pPr>
             <a:r>
@@ -10278,7 +10230,7 @@
           <a:bodyPr wrap="square" lIns="0" tIns="0" rIns="0" bIns="0" rtlCol="0" anchor="ctr"/>
           <a:lstStyle/>
           <a:p>
-            <a:pPr indent="0" marL="0">
+            <a:pPr marL="0" indent="0">
               <a:buNone/>
             </a:pPr>
             <a:r>
@@ -10339,11 +10291,11 @@
           <a:bodyPr wrap="square" lIns="0" tIns="0" rIns="0" bIns="0" rtlCol="0" anchor="ctr"/>
           <a:lstStyle/>
           <a:p>
-            <a:pPr algn="ctr" indent="0" marL="0">
-              <a:buNone/>
-            </a:pPr>
-            <a:r>
-              <a:rPr lang="en-US" sz="1300" b="1" spc="200" kern="0" dirty="0">
+            <a:pPr marL="0" indent="0" algn="ctr">
+              <a:buNone/>
+            </a:pPr>
+            <a:r>
+              <a:rPr lang="en-US" sz="1300" b="1" kern="0" spc="200" dirty="0">
                 <a:solidFill>
                   <a:srgbClr val="2E7D32"/>
                 </a:solidFill>
@@ -10378,7 +10330,7 @@
           <a:bodyPr wrap="square" lIns="0" tIns="0" rIns="0" bIns="0" rtlCol="0" anchor="ctr"/>
           <a:lstStyle/>
           <a:p>
-            <a:pPr algn="ctr" indent="0" marL="0">
+            <a:pPr marL="0" indent="0" algn="ctr">
               <a:buNone/>
             </a:pPr>
             <a:r>
@@ -10417,7 +10369,7 @@
           <a:bodyPr wrap="square" lIns="0" tIns="0" rIns="0" bIns="0" rtlCol="0" anchor="ctr"/>
           <a:lstStyle/>
           <a:p>
-            <a:pPr algn="ctr" indent="0" marL="0">
+            <a:pPr marL="0" indent="0" algn="ctr">
               <a:buNone/>
             </a:pPr>
             <a:r>
@@ -10456,7 +10408,7 @@
           <a:bodyPr wrap="square" lIns="0" tIns="0" rIns="0" bIns="0" rtlCol="0" anchor="ctr"/>
           <a:lstStyle/>
           <a:p>
-            <a:pPr algn="ctr" indent="0" marL="0">
+            <a:pPr marL="0" indent="0" algn="ctr">
               <a:buNone/>
             </a:pPr>
             <a:r>
@@ -10495,7 +10447,7 @@
           <a:bodyPr wrap="square" lIns="0" tIns="0" rIns="0" bIns="0" rtlCol="0" anchor="ctr"/>
           <a:lstStyle/>
           <a:p>
-            <a:pPr algn="ctr" indent="0" marL="0">
+            <a:pPr marL="0" indent="0" algn="ctr">
               <a:buNone/>
             </a:pPr>
             <a:r>
@@ -10529,6 +10481,7 @@
         <a:solidFill>
           <a:srgbClr val="FFFFFF"/>
         </a:solidFill>
+        <a:effectLst/>
       </p:bgPr>
     </p:bg>
     <p:spTree>
@@ -10566,7 +10519,7 @@
           <a:bodyPr wrap="square" rtlCol="0" anchor="ctr"/>
           <a:lstStyle/>
           <a:p>
-            <a:pPr indent="0" marL="0">
+            <a:pPr marL="0" indent="0">
               <a:buNone/>
             </a:pPr>
             <a:r>
@@ -10605,7 +10558,7 @@
           <a:bodyPr wrap="square" rtlCol="0" anchor="ctr"/>
           <a:lstStyle/>
           <a:p>
-            <a:pPr indent="0" marL="0">
+            <a:pPr marL="0" indent="0">
               <a:buNone/>
             </a:pPr>
             <a:r>
@@ -10644,7 +10597,7 @@
           </a:solidFill>
           <a:ln/>
           <a:effectLst>
-            <a:outerShdw sx="100000" sy="100000" kx="0" ky="0" algn="bl" rotWithShape="0" blurRad="76200" dist="25400" dir="5400000">
+            <a:outerShdw blurRad="76200" dist="25400" dir="5400000" algn="bl" rotWithShape="0">
               <a:srgbClr val="999999">
                 <a:alpha val="35000"/>
               </a:srgbClr>
@@ -10673,7 +10626,7 @@
           <a:bodyPr wrap="square" lIns="0" tIns="0" rIns="0" bIns="0" rtlCol="0" anchor="ctr"/>
           <a:lstStyle/>
           <a:p>
-            <a:pPr indent="0" marL="0">
+            <a:pPr marL="0" indent="0">
               <a:buNone/>
             </a:pPr>
             <a:r>
@@ -10734,7 +10687,7 @@
           <a:bodyPr wrap="square" lIns="0" tIns="0" rIns="0" bIns="0" rtlCol="0" anchor="ctr"/>
           <a:lstStyle/>
           <a:p>
-            <a:pPr indent="0" marL="0">
+            <a:pPr marL="0" indent="0">
               <a:buNone/>
             </a:pPr>
             <a:r>
@@ -10749,9 +10702,6 @@
               <a:t>R02 · Apellidos distintos
 </a:t>
             </a:r>
-            <a:pPr indent="0" marL="0">
-              <a:buNone/>
-            </a:pPr>
             <a:r>
               <a:rPr lang="en-US" sz="1300" dirty="0">
                 <a:solidFill>
@@ -10763,9 +10713,6 @@
               </a:rPr>
               <a:t>El DNI dice </a:t>
             </a:r>
-            <a:pPr indent="0" marL="0">
-              <a:buNone/>
-            </a:pPr>
             <a:r>
               <a:rPr lang="en-US" sz="1300" dirty="0">
                 <a:solidFill>
@@ -10777,9 +10724,6 @@
               </a:rPr>
               <a:t>GARCÍA RUIZ</a:t>
             </a:r>
-            <a:pPr indent="0" marL="0">
-              <a:buNone/>
-            </a:pPr>
             <a:r>
               <a:rPr lang="en-US" sz="1300" dirty="0">
                 <a:solidFill>
@@ -10791,9 +10735,6 @@
               </a:rPr>
               <a:t> pero el formulario dice </a:t>
             </a:r>
-            <a:pPr indent="0" marL="0">
-              <a:buNone/>
-            </a:pPr>
             <a:r>
               <a:rPr lang="en-US" sz="1300" dirty="0">
                 <a:solidFill>
@@ -10805,9 +10746,6 @@
               </a:rPr>
               <a:t>GÓMEZ RUIZ</a:t>
             </a:r>
-            <a:pPr indent="0" marL="0">
-              <a:buNone/>
-            </a:pPr>
             <a:r>
               <a:rPr lang="en-US" sz="1300" dirty="0">
                 <a:solidFill>
@@ -10866,7 +10804,7 @@
           <a:bodyPr wrap="square" lIns="0" tIns="0" rIns="0" bIns="0" rtlCol="0" anchor="ctr"/>
           <a:lstStyle/>
           <a:p>
-            <a:pPr indent="0" marL="0">
+            <a:pPr marL="0" indent="0">
               <a:buNone/>
             </a:pPr>
             <a:r>
@@ -10881,9 +10819,6 @@
               <a:t>R07 · Endeudamiento excesivo
 </a:t>
             </a:r>
-            <a:pPr indent="0" marL="0">
-              <a:buNone/>
-            </a:pPr>
             <a:r>
               <a:rPr lang="en-US" sz="1300" dirty="0">
                 <a:solidFill>
@@ -10942,11 +10877,11 @@
           <a:bodyPr wrap="square" lIns="0" tIns="0" rIns="0" bIns="0" rtlCol="0" anchor="ctr"/>
           <a:lstStyle/>
           <a:p>
-            <a:pPr algn="ctr" indent="0" marL="0">
-              <a:buNone/>
-            </a:pPr>
-            <a:r>
-              <a:rPr lang="en-US" sz="1300" b="1" spc="200" kern="0" dirty="0">
+            <a:pPr marL="0" indent="0" algn="ctr">
+              <a:buNone/>
+            </a:pPr>
+            <a:r>
+              <a:rPr lang="en-US" sz="1300" b="1" kern="0" spc="200" dirty="0">
                 <a:solidFill>
                   <a:srgbClr val="C62828"/>
                 </a:solidFill>
@@ -10981,7 +10916,7 @@
           <a:bodyPr wrap="square" lIns="0" tIns="0" rIns="0" bIns="0" rtlCol="0" anchor="ctr"/>
           <a:lstStyle/>
           <a:p>
-            <a:pPr algn="ctr" indent="0" marL="0">
+            <a:pPr marL="0" indent="0" algn="ctr">
               <a:buNone/>
             </a:pPr>
             <a:r>
@@ -11020,7 +10955,7 @@
           <a:bodyPr wrap="square" lIns="0" tIns="0" rIns="0" bIns="0" rtlCol="0" anchor="ctr"/>
           <a:lstStyle/>
           <a:p>
-            <a:pPr algn="ctr" indent="0" marL="0">
+            <a:pPr marL="0" indent="0" algn="ctr">
               <a:buNone/>
             </a:pPr>
             <a:r>
@@ -11059,7 +10994,7 @@
           <a:bodyPr wrap="square" lIns="0" tIns="0" rIns="0" bIns="0" rtlCol="0" anchor="ctr"/>
           <a:lstStyle/>
           <a:p>
-            <a:pPr algn="ctr" indent="0" marL="0">
+            <a:pPr marL="0" indent="0" algn="ctr">
               <a:buNone/>
             </a:pPr>
             <a:r>
@@ -11098,7 +11033,7 @@
           <a:bodyPr wrap="square" lIns="0" tIns="0" rIns="0" bIns="0" rtlCol="0" anchor="ctr"/>
           <a:lstStyle/>
           <a:p>
-            <a:pPr algn="ctr" indent="0" marL="0">
+            <a:pPr marL="0" indent="0" algn="ctr">
               <a:buNone/>
             </a:pPr>
             <a:r>
@@ -11115,7 +11050,7 @@
             <a:endParaRPr lang="en-US" sz="1200" dirty="0"/>
           </a:p>
           <a:p>
-            <a:pPr algn="ctr" indent="0" marL="0">
+            <a:pPr marL="0" indent="0" algn="ctr">
               <a:buNone/>
             </a:pPr>
             <a:r>
@@ -11434,4 +11369,299 @@
     </a:ext>
   </a:extLst>
 </a:theme>
+</file>
+
+<file path=ppt/theme/theme2.xml><?xml version="1.0" encoding="utf-8"?>
+<a:theme xmlns:a="http://schemas.openxmlformats.org/drawingml/2006/main" name="Tema de Office">
+  <a:themeElements>
+    <a:clrScheme name="Office">
+      <a:dk1>
+        <a:sysClr val="windowText" lastClr="000000"/>
+      </a:dk1>
+      <a:lt1>
+        <a:sysClr val="window" lastClr="FFFFFF"/>
+      </a:lt1>
+      <a:dk2>
+        <a:srgbClr val="44546A"/>
+      </a:dk2>
+      <a:lt2>
+        <a:srgbClr val="E7E6E6"/>
+      </a:lt2>
+      <a:accent1>
+        <a:srgbClr val="4472C4"/>
+      </a:accent1>
+      <a:accent2>
+        <a:srgbClr val="ED7D31"/>
+      </a:accent2>
+      <a:accent3>
+        <a:srgbClr val="A5A5A5"/>
+      </a:accent3>
+      <a:accent4>
+        <a:srgbClr val="FFC000"/>
+      </a:accent4>
+      <a:accent5>
+        <a:srgbClr val="5B9BD5"/>
+      </a:accent5>
+      <a:accent6>
+        <a:srgbClr val="70AD47"/>
+      </a:accent6>
+      <a:hlink>
+        <a:srgbClr val="0563C1"/>
+      </a:hlink>
+      <a:folHlink>
+        <a:srgbClr val="954F72"/>
+      </a:folHlink>
+    </a:clrScheme>
+    <a:fontScheme name="Office">
+      <a:majorFont>
+        <a:latin typeface="Calibri Light" panose="020F0302020204030204"/>
+        <a:ea typeface=""/>
+        <a:cs typeface=""/>
+        <a:font script="Jpan" typeface="游ゴシック Light"/>
+        <a:font script="Hang" typeface="맑은 고딕"/>
+        <a:font script="Hans" typeface="等线 Light"/>
+        <a:font script="Hant" typeface="新細明體"/>
+        <a:font script="Arab" typeface="Times New Roman"/>
+        <a:font script="Hebr" typeface="Times New Roman"/>
+        <a:font script="Thai" typeface="Angsana New"/>
+        <a:font script="Ethi" typeface="Nyala"/>
+        <a:font script="Beng" typeface="Vrinda"/>
+        <a:font script="Gujr" typeface="Shruti"/>
+        <a:font script="Khmr" typeface="MoolBoran"/>
+        <a:font script="Knda" typeface="Tunga"/>
+        <a:font script="Guru" typeface="Raavi"/>
+        <a:font script="Cans" typeface="Euphemia"/>
+        <a:font script="Cher" typeface="Plantagenet Cherokee"/>
+        <a:font script="Yiii" typeface="Microsoft Yi Baiti"/>
+        <a:font script="Tibt" typeface="Microsoft Himalaya"/>
+        <a:font script="Thaa" typeface="MV Boli"/>
+        <a:font script="Deva" typeface="Mangal"/>
+        <a:font script="Telu" typeface="Gautami"/>
+        <a:font script="Taml" typeface="Latha"/>
+        <a:font script="Syrc" typeface="Estrangelo Edessa"/>
+        <a:font script="Orya" typeface="Kalinga"/>
+        <a:font script="Mlym" typeface="Kartika"/>
+        <a:font script="Laoo" typeface="DokChampa"/>
+        <a:font script="Sinh" typeface="Iskoola Pota"/>
+        <a:font script="Mong" typeface="Mongolian Baiti"/>
+        <a:font script="Viet" typeface="Times New Roman"/>
+        <a:font script="Uigh" typeface="Microsoft Uighur"/>
+        <a:font script="Geor" typeface="Sylfaen"/>
+        <a:font script="Armn" typeface="Arial"/>
+        <a:font script="Bugi" typeface="Leelawadee UI"/>
+        <a:font script="Bopo" typeface="Microsoft JhengHei"/>
+        <a:font script="Java" typeface="Javanese Text"/>
+        <a:font script="Lisu" typeface="Segoe UI"/>
+        <a:font script="Mymr" typeface="Myanmar Text"/>
+        <a:font script="Nkoo" typeface="Ebrima"/>
+        <a:font script="Olck" typeface="Nirmala UI"/>
+        <a:font script="Osma" typeface="Ebrima"/>
+        <a:font script="Phag" typeface="Phagspa"/>
+        <a:font script="Syrn" typeface="Estrangelo Edessa"/>
+        <a:font script="Syrj" typeface="Estrangelo Edessa"/>
+        <a:font script="Syre" typeface="Estrangelo Edessa"/>
+        <a:font script="Sora" typeface="Nirmala UI"/>
+        <a:font script="Tale" typeface="Microsoft Tai Le"/>
+        <a:font script="Talu" typeface="Microsoft New Tai Lue"/>
+        <a:font script="Tfng" typeface="Ebrima"/>
+      </a:majorFont>
+      <a:minorFont>
+        <a:latin typeface="Calibri" panose="020F0502020204030204"/>
+        <a:ea typeface=""/>
+        <a:cs typeface=""/>
+        <a:font script="Jpan" typeface="游ゴシック"/>
+        <a:font script="Hang" typeface="맑은 고딕"/>
+        <a:font script="Hans" typeface="等线"/>
+        <a:font script="Hant" typeface="新細明體"/>
+        <a:font script="Arab" typeface="Arial"/>
+        <a:font script="Hebr" typeface="Arial"/>
+        <a:font script="Thai" typeface="Cordia New"/>
+        <a:font script="Ethi" typeface="Nyala"/>
+        <a:font script="Beng" typeface="Vrinda"/>
+        <a:font script="Gujr" typeface="Shruti"/>
+        <a:font script="Khmr" typeface="DaunPenh"/>
+        <a:font script="Knda" typeface="Tunga"/>
+        <a:font script="Guru" typeface="Raavi"/>
+        <a:font script="Cans" typeface="Euphemia"/>
+        <a:font script="Cher" typeface="Plantagenet Cherokee"/>
+        <a:font script="Yiii" typeface="Microsoft Yi Baiti"/>
+        <a:font script="Tibt" typeface="Microsoft Himalaya"/>
+        <a:font script="Thaa" typeface="MV Boli"/>
+        <a:font script="Deva" typeface="Mangal"/>
+        <a:font script="Telu" typeface="Gautami"/>
+        <a:font script="Taml" typeface="Latha"/>
+        <a:font script="Syrc" typeface="Estrangelo Edessa"/>
+        <a:font script="Orya" typeface="Kalinga"/>
+        <a:font script="Mlym" typeface="Kartika"/>
+        <a:font script="Laoo" typeface="DokChampa"/>
+        <a:font script="Sinh" typeface="Iskoola Pota"/>
+        <a:font script="Mong" typeface="Mongolian Baiti"/>
+        <a:font script="Viet" typeface="Arial"/>
+        <a:font script="Uigh" typeface="Microsoft Uighur"/>
+        <a:font script="Geor" typeface="Sylfaen"/>
+        <a:font script="Armn" typeface="Arial"/>
+        <a:font script="Bugi" typeface="Leelawadee UI"/>
+        <a:font script="Bopo" typeface="Microsoft JhengHei"/>
+        <a:font script="Java" typeface="Javanese Text"/>
+        <a:font script="Lisu" typeface="Segoe UI"/>
+        <a:font script="Mymr" typeface="Myanmar Text"/>
+        <a:font script="Nkoo" typeface="Ebrima"/>
+        <a:font script="Olck" typeface="Nirmala UI"/>
+        <a:font script="Osma" typeface="Ebrima"/>
+        <a:font script="Phag" typeface="Phagspa"/>
+        <a:font script="Syrn" typeface="Estrangelo Edessa"/>
+        <a:font script="Syrj" typeface="Estrangelo Edessa"/>
+        <a:font script="Syre" typeface="Estrangelo Edessa"/>
+        <a:font script="Sora" typeface="Nirmala UI"/>
+        <a:font script="Tale" typeface="Microsoft Tai Le"/>
+        <a:font script="Talu" typeface="Microsoft New Tai Lue"/>
+        <a:font script="Tfng" typeface="Ebrima"/>
+      </a:minorFont>
+    </a:fontScheme>
+    <a:fmtScheme name="Office">
+      <a:fillStyleLst>
+        <a:solidFill>
+          <a:schemeClr val="phClr"/>
+        </a:solidFill>
+        <a:gradFill rotWithShape="1">
+          <a:gsLst>
+            <a:gs pos="0">
+              <a:schemeClr val="phClr">
+                <a:lumMod val="110000"/>
+                <a:satMod val="105000"/>
+                <a:tint val="67000"/>
+              </a:schemeClr>
+            </a:gs>
+            <a:gs pos="50000">
+              <a:schemeClr val="phClr">
+                <a:lumMod val="105000"/>
+                <a:satMod val="103000"/>
+                <a:tint val="73000"/>
+              </a:schemeClr>
+            </a:gs>
+            <a:gs pos="100000">
+              <a:schemeClr val="phClr">
+                <a:lumMod val="105000"/>
+                <a:satMod val="109000"/>
+                <a:tint val="81000"/>
+              </a:schemeClr>
+            </a:gs>
+          </a:gsLst>
+          <a:lin ang="5400000" scaled="0"/>
+        </a:gradFill>
+        <a:gradFill rotWithShape="1">
+          <a:gsLst>
+            <a:gs pos="0">
+              <a:schemeClr val="phClr">
+                <a:satMod val="103000"/>
+                <a:lumMod val="102000"/>
+                <a:tint val="94000"/>
+              </a:schemeClr>
+            </a:gs>
+            <a:gs pos="50000">
+              <a:schemeClr val="phClr">
+                <a:satMod val="110000"/>
+                <a:lumMod val="100000"/>
+                <a:shade val="100000"/>
+              </a:schemeClr>
+            </a:gs>
+            <a:gs pos="100000">
+              <a:schemeClr val="phClr">
+                <a:lumMod val="99000"/>
+                <a:satMod val="120000"/>
+                <a:shade val="78000"/>
+              </a:schemeClr>
+            </a:gs>
+          </a:gsLst>
+          <a:lin ang="5400000" scaled="0"/>
+        </a:gradFill>
+      </a:fillStyleLst>
+      <a:lnStyleLst>
+        <a:ln w="6350" cap="flat" cmpd="sng" algn="ctr">
+          <a:solidFill>
+            <a:schemeClr val="phClr"/>
+          </a:solidFill>
+          <a:prstDash val="solid"/>
+          <a:miter lim="800000"/>
+        </a:ln>
+        <a:ln w="12700" cap="flat" cmpd="sng" algn="ctr">
+          <a:solidFill>
+            <a:schemeClr val="phClr"/>
+          </a:solidFill>
+          <a:prstDash val="solid"/>
+          <a:miter lim="800000"/>
+        </a:ln>
+        <a:ln w="19050" cap="flat" cmpd="sng" algn="ctr">
+          <a:solidFill>
+            <a:schemeClr val="phClr"/>
+          </a:solidFill>
+          <a:prstDash val="solid"/>
+          <a:miter lim="800000"/>
+        </a:ln>
+      </a:lnStyleLst>
+      <a:effectStyleLst>
+        <a:effectStyle>
+          <a:effectLst/>
+        </a:effectStyle>
+        <a:effectStyle>
+          <a:effectLst/>
+        </a:effectStyle>
+        <a:effectStyle>
+          <a:effectLst>
+            <a:outerShdw blurRad="57150" dist="19050" dir="5400000" algn="ctr" rotWithShape="0">
+              <a:srgbClr val="000000">
+                <a:alpha val="63000"/>
+              </a:srgbClr>
+            </a:outerShdw>
+          </a:effectLst>
+        </a:effectStyle>
+      </a:effectStyleLst>
+      <a:bgFillStyleLst>
+        <a:solidFill>
+          <a:schemeClr val="phClr"/>
+        </a:solidFill>
+        <a:solidFill>
+          <a:schemeClr val="phClr">
+            <a:tint val="95000"/>
+            <a:satMod val="170000"/>
+          </a:schemeClr>
+        </a:solidFill>
+        <a:gradFill rotWithShape="1">
+          <a:gsLst>
+            <a:gs pos="0">
+              <a:schemeClr val="phClr">
+                <a:tint val="93000"/>
+                <a:satMod val="150000"/>
+                <a:shade val="98000"/>
+                <a:lumMod val="102000"/>
+              </a:schemeClr>
+            </a:gs>
+            <a:gs pos="50000">
+              <a:schemeClr val="phClr">
+                <a:tint val="98000"/>
+                <a:satMod val="130000"/>
+                <a:shade val="90000"/>
+                <a:lumMod val="103000"/>
+              </a:schemeClr>
+            </a:gs>
+            <a:gs pos="100000">
+              <a:schemeClr val="phClr">
+                <a:shade val="63000"/>
+                <a:satMod val="120000"/>
+              </a:schemeClr>
+            </a:gs>
+          </a:gsLst>
+          <a:lin ang="5400000" scaled="0"/>
+        </a:gradFill>
+      </a:bgFillStyleLst>
+    </a:fmtScheme>
+  </a:themeElements>
+  <a:objectDefaults/>
+  <a:extraClrSchemeLst/>
+  <a:extLst>
+    <a:ext uri="{05A4C25C-085E-4340-85A3-A5531E510DB2}">
+      <thm15:themeFamily xmlns:thm15="http://schemas.microsoft.com/office/thememl/2012/main" name="Office Theme" id="{62F939B6-93AF-4DB8-9C6B-D6C7DFDC589F}" vid="{4A3C46E8-61CC-4603-A589-7422A47A8E4A}"/>
+    </a:ext>
+  </a:extLst>
+</a:theme>
 </file>
</xml_diff>